<commit_message>
feat: Noite 2 - fichas de identificacao de roteador e cabo
Folha do aluno passa a ter 5 paginas: leitura guiada da etiqueta do
roteador (TL-WR840N e Archer C5 da bancada), luzes e perguntas de
tecnico, e ficha de identificacao de cabo Cat5e x Cat6. Tarefa da
semana alinhada no roteiro e nos slides.

Co-Authored-By: Claude Opus 5.5 <noreply@anthropic.com>
Claude-Session: https://claude.ai/code/session_017UWKnGnU4rSnDUBwGRiA1e
</commit_message>
<xml_diff>
--- a/Aula - Redes 2 - Como a internet chega.pptx
+++ b/Aula - Redes 2 - Como a internet chega.pptx
@@ -9385,7 +9385,7 @@
                   <a:srgbClr val="1A1A1A"/>
                 </a:solidFill>
               </a:rPr>
-              <a:t>Duas tarefas simples:</a:t>
+              <a:t>Uma tarefa simples:</a:t>
             </a:r>
           </a:p>
           <a:p>
@@ -9407,7 +9407,7 @@
                   <a:srgbClr val="1A1A1A"/>
                 </a:solidFill>
               </a:rPr>
-              <a:t>•  Procurar um cabo de rede em casa e ler o que está escrito na capa</a:t>
+              <a:t>•  Ler a etiqueta do roteador da sua casa</a:t>
             </a:r>
           </a:p>
           <a:p>
@@ -9418,7 +9418,7 @@
                   <a:srgbClr val="1A1A1A"/>
                 </a:solidFill>
               </a:rPr>
-              <a:t>•  Anotar a categoria, o fabricante e o número da metragem</a:t>
+              <a:t>•  Anotar marca, modelo, velocidade do Wi-Fi e se é Dual Band (senha NÃO)</a:t>
             </a:r>
           </a:p>
           <a:p>
@@ -9429,7 +9429,7 @@
                   <a:srgbClr val="1A1A1A"/>
                 </a:solidFill>
               </a:rPr>
-              <a:t>•  Se não achar cabo de rede, sirva qualquer cabo (TV, energia)</a:t>
+              <a:t>•  Senha não se anota nem se fotografa — tampe com o dedo</a:t>
             </a:r>
           </a:p>
           <a:p>
@@ -9440,7 +9440,7 @@
                   <a:srgbClr val="1A1A1A"/>
                 </a:solidFill>
               </a:rPr>
-              <a:t>•  Trazer anotado — vamos comparar as capas na aula</a:t>
+              <a:t>•  Trazer anotado — vamos comparar os aparelhos da turma</a:t>
             </a:r>
           </a:p>
           <a:p>
@@ -9462,7 +9462,7 @@
                   <a:srgbClr val="1A1A1A"/>
                 </a:solidFill>
               </a:rPr>
-              <a:t>Quem não achar nenhum, sem problema — vai ter cabo de sobra na mesa.</a:t>
+              <a:t>Quem não tem roteador em casa: olhe o de um parente ou vizinho.</a:t>
             </a:r>
           </a:p>
         </p:txBody>

</xml_diff>

<commit_message>
feat: Noite 2 - ficha do modem de fibra (ONU)
</commit_message>
<xml_diff>
--- a/Aula - Redes 2 - Como a internet chega.pptx
+++ b/Aula - Redes 2 - Como a internet chega.pptx
@@ -34,6 +34,7 @@
     <p:sldId id="282" r:id="rId33"/>
     <p:sldId id="283" r:id="rId34"/>
     <p:sldId id="284" r:id="rId35"/>
+    <p:sldId id="285" r:id="rId36"/>
   </p:sldIdLst>
   <p:sldSz cx="12191695" cy="6858000" type="screen4x3"/>
   <p:notesSz cx="6858000" cy="9144000"/>
@@ -7759,7 +7760,7 @@
                   <a:srgbClr val="1A1A1A"/>
                 </a:solidFill>
               </a:rPr>
-              <a:t>6.  Ler a capa de um cabo Cat5e e de um Cat6 (página 5)</a:t>
+              <a:t>6.  Ler a etiqueta dos dois modems de fibra (página 5)</a:t>
             </a:r>
           </a:p>
           <a:p>
@@ -7770,7 +7771,18 @@
                   <a:srgbClr val="1A1A1A"/>
                 </a:solidFill>
               </a:rPr>
-              <a:t>7.  Trocar de bancada e conferir o que a outra equipe anotou</a:t>
+              <a:t>7.  Ler a capa de um cabo Cat5e e de um Cat6 (página 6)</a:t>
+            </a:r>
+          </a:p>
+          <a:p>
+            <a:pPr algn="l"/>
+            <a:r>
+              <a:rPr sz="1600" b="0" i="0">
+                <a:solidFill>
+                  <a:srgbClr val="1A1A1A"/>
+                </a:solidFill>
+              </a:rPr>
+              <a:t>8.  Trocar de bancada e conferir o que a outra equipe anotou</a:t>
             </a:r>
           </a:p>
         </p:txBody>
@@ -9286,6 +9298,625 @@
                   <a:srgbClr val="0B5C5C"/>
                 </a:solidFill>
               </a:rPr>
+              <a:t>Os dois modems de fibra (ONU)</a:t>
+            </a:r>
+          </a:p>
+        </p:txBody>
+      </p:sp>
+      <p:sp>
+        <p:nvSpPr>
+          <p:cNvPr id="5" name="Rectangle 4"/>
+          <p:cNvSpPr/>
+          <p:nvPr/>
+        </p:nvSpPr>
+        <p:spPr>
+          <a:xfrm>
+            <a:off x="640080" y="1554480"/>
+            <a:ext cx="10881360" cy="54864"/>
+          </a:xfrm>
+          <a:prstGeom prst="rect">
+            <a:avLst/>
+          </a:prstGeom>
+          <a:solidFill>
+            <a:srgbClr val="0B5C5C"/>
+          </a:solidFill>
+          <a:ln>
+            <a:noFill/>
+          </a:ln>
+        </p:spPr>
+        <p:style>
+          <a:lnRef idx="1">
+            <a:schemeClr val="accent1"/>
+          </a:lnRef>
+          <a:fillRef idx="3">
+            <a:schemeClr val="accent1"/>
+          </a:fillRef>
+          <a:effectRef idx="2">
+            <a:schemeClr val="accent1"/>
+          </a:effectRef>
+          <a:fontRef idx="minor">
+            <a:schemeClr val="lt1"/>
+          </a:fontRef>
+        </p:style>
+        <p:txBody>
+          <a:bodyPr rtlCol="0" anchor="ctr"/>
+          <a:lstStyle/>
+          <a:p>
+            <a:pPr algn="ctr"/>
+          </a:p>
+        </p:txBody>
+      </p:sp>
+      <p:graphicFrame>
+        <p:nvGraphicFramePr>
+          <p:cNvPr id="6" name="Table 5"/>
+          <p:cNvGraphicFramePr>
+            <a:graphicFrameLocks noGrp="1"/>
+          </p:cNvGraphicFramePr>
+          <p:nvPr/>
+        </p:nvGraphicFramePr>
+        <p:xfrm>
+          <a:off x="640080" y="2103120"/>
+          <a:ext cx="10881360" cy="3017520"/>
+        </p:xfrm>
+        <a:graphic>
+          <a:graphicData uri="http://schemas.openxmlformats.org/drawingml/2006/table">
+            <a:tbl>
+              <a:tblPr firstRow="1" bandRow="1">
+                <a:tableStyleId>{5C22544A-7EE6-4342-B048-85BDC9FD1C3A}</a:tableStyleId>
+              </a:tblPr>
+              <a:tblGrid>
+                <a:gridCol w="3291840"/>
+                <a:gridCol w="4023360"/>
+                <a:gridCol w="3566160"/>
+              </a:tblGrid>
+              <a:tr h="502920">
+                <a:tc>
+                  <a:txBody>
+                    <a:bodyPr/>
+                    <a:lstStyle/>
+                    <a:p>
+                      <a:r>
+                        <a:rPr sz="1400" b="1">
+                          <a:solidFill>
+                            <a:srgbClr val="FFFFFF"/>
+                          </a:solidFill>
+                        </a:rPr>
+                        <a:t>Item</a:t>
+                      </a:r>
+                    </a:p>
+                  </a:txBody>
+                  <a:tcPr>
+                    <a:solidFill>
+                      <a:srgbClr val="0B5C5C"/>
+                    </a:solidFill>
+                  </a:tcPr>
+                </a:tc>
+                <a:tc>
+                  <a:txBody>
+                    <a:bodyPr/>
+                    <a:lstStyle/>
+                    <a:p>
+                      <a:r>
+                        <a:rPr sz="1400" b="1">
+                          <a:solidFill>
+                            <a:srgbClr val="FFFFFF"/>
+                          </a:solidFill>
+                        </a:rPr>
+                        <a:t>HG6143D</a:t>
+                      </a:r>
+                    </a:p>
+                  </a:txBody>
+                  <a:tcPr>
+                    <a:solidFill>
+                      <a:srgbClr val="0B5C5C"/>
+                    </a:solidFill>
+                  </a:tcPr>
+                </a:tc>
+                <a:tc>
+                  <a:txBody>
+                    <a:bodyPr/>
+                    <a:lstStyle/>
+                    <a:p>
+                      <a:r>
+                        <a:rPr sz="1400" b="1">
+                          <a:solidFill>
+                            <a:srgbClr val="FFFFFF"/>
+                          </a:solidFill>
+                        </a:rPr>
+                        <a:t>AN5506-02-B</a:t>
+                      </a:r>
+                    </a:p>
+                  </a:txBody>
+                  <a:tcPr>
+                    <a:solidFill>
+                      <a:srgbClr val="0B5C5C"/>
+                    </a:solidFill>
+                  </a:tcPr>
+                </a:tc>
+              </a:tr>
+              <a:tr h="502920">
+                <a:tc>
+                  <a:txBody>
+                    <a:bodyPr/>
+                    <a:lstStyle/>
+                    <a:p>
+                      <a:r>
+                        <a:rPr sz="1400" b="0">
+                          <a:solidFill>
+                            <a:srgbClr val="1A1A1A"/>
+                          </a:solidFill>
+                        </a:rPr>
+                        <a:t>Marca / tipo</a:t>
+                      </a:r>
+                    </a:p>
+                  </a:txBody>
+                  <a:tcPr/>
+                </a:tc>
+                <a:tc>
+                  <a:txBody>
+                    <a:bodyPr/>
+                    <a:lstStyle/>
+                    <a:p>
+                      <a:r>
+                        <a:rPr sz="1400" b="0">
+                          <a:solidFill>
+                            <a:srgbClr val="1A1A1A"/>
+                          </a:solidFill>
+                        </a:rPr>
+                        <a:t>FiberHome · GPON ONU</a:t>
+                      </a:r>
+                    </a:p>
+                  </a:txBody>
+                  <a:tcPr/>
+                </a:tc>
+                <a:tc>
+                  <a:txBody>
+                    <a:bodyPr/>
+                    <a:lstStyle/>
+                    <a:p>
+                      <a:r>
+                        <a:rPr sz="1400" b="0">
+                          <a:solidFill>
+                            <a:srgbClr val="1A1A1A"/>
+                          </a:solidFill>
+                        </a:rPr>
+                        <a:t>FiberHome · GPON ONU</a:t>
+                      </a:r>
+                    </a:p>
+                  </a:txBody>
+                  <a:tcPr/>
+                </a:tc>
+              </a:tr>
+              <a:tr h="502920">
+                <a:tc>
+                  <a:txBody>
+                    <a:bodyPr/>
+                    <a:lstStyle/>
+                    <a:p>
+                      <a:r>
+                        <a:rPr sz="1400" b="0">
+                          <a:solidFill>
+                            <a:srgbClr val="1A1A1A"/>
+                          </a:solidFill>
+                        </a:rPr>
+                        <a:t>Tem Wi-Fi?</a:t>
+                      </a:r>
+                    </a:p>
+                  </a:txBody>
+                  <a:tcPr/>
+                </a:tc>
+                <a:tc>
+                  <a:txBody>
+                    <a:bodyPr/>
+                    <a:lstStyle/>
+                    <a:p>
+                      <a:r>
+                        <a:rPr sz="1400" b="0">
+                          <a:solidFill>
+                            <a:srgbClr val="1A1A1A"/>
+                          </a:solidFill>
+                        </a:rPr>
+                        <a:t>Sim, Dual Band (fh_… e fh_…_5G)</a:t>
+                      </a:r>
+                    </a:p>
+                  </a:txBody>
+                  <a:tcPr/>
+                </a:tc>
+                <a:tc>
+                  <a:txBody>
+                    <a:bodyPr/>
+                    <a:lstStyle/>
+                    <a:p>
+                      <a:r>
+                        <a:rPr sz="1400" b="0">
+                          <a:solidFill>
+                            <a:srgbClr val="1A1A1A"/>
+                          </a:solidFill>
+                        </a:rPr>
+                        <a:t>Não — sem SSID na etiqueta</a:t>
+                      </a:r>
+                    </a:p>
+                  </a:txBody>
+                  <a:tcPr/>
+                </a:tc>
+              </a:tr>
+              <a:tr h="502920">
+                <a:tc>
+                  <a:txBody>
+                    <a:bodyPr/>
+                    <a:lstStyle/>
+                    <a:p>
+                      <a:r>
+                        <a:rPr sz="1400" b="0">
+                          <a:solidFill>
+                            <a:srgbClr val="1A1A1A"/>
+                          </a:solidFill>
+                        </a:rPr>
+                        <a:t>Alimentação</a:t>
+                      </a:r>
+                    </a:p>
+                  </a:txBody>
+                  <a:tcPr/>
+                </a:tc>
+                <a:tc>
+                  <a:txBody>
+                    <a:bodyPr/>
+                    <a:lstStyle/>
+                    <a:p>
+                      <a:r>
+                        <a:rPr sz="1400" b="0">
+                          <a:solidFill>
+                            <a:srgbClr val="1A1A1A"/>
+                          </a:solidFill>
+                        </a:rPr>
+                        <a:t>12V ⎓ 1,5A</a:t>
+                      </a:r>
+                    </a:p>
+                  </a:txBody>
+                  <a:tcPr/>
+                </a:tc>
+                <a:tc>
+                  <a:txBody>
+                    <a:bodyPr/>
+                    <a:lstStyle/>
+                    <a:p>
+                      <a:r>
+                        <a:rPr sz="1400" b="0">
+                          <a:solidFill>
+                            <a:srgbClr val="1A1A1A"/>
+                          </a:solidFill>
+                        </a:rPr>
+                        <a:t>12V ⎓ 1A</a:t>
+                      </a:r>
+                    </a:p>
+                  </a:txBody>
+                  <a:tcPr/>
+                </a:tc>
+              </a:tr>
+              <a:tr h="502920">
+                <a:tc>
+                  <a:txBody>
+                    <a:bodyPr/>
+                    <a:lstStyle/>
+                    <a:p>
+                      <a:r>
+                        <a:rPr sz="1400" b="0">
+                          <a:solidFill>
+                            <a:srgbClr val="1A1A1A"/>
+                          </a:solidFill>
+                        </a:rPr>
+                        <a:t>Acesso de configuração</a:t>
+                      </a:r>
+                    </a:p>
+                  </a:txBody>
+                  <a:tcPr/>
+                </a:tc>
+                <a:tc>
+                  <a:txBody>
+                    <a:bodyPr/>
+                    <a:lstStyle/>
+                    <a:p>
+                      <a:r>
+                        <a:rPr sz="1400" b="0">
+                          <a:solidFill>
+                            <a:srgbClr val="1A1A1A"/>
+                          </a:solidFill>
+                        </a:rPr>
+                        <a:t>192.168.1.1 · user / user1234</a:t>
+                      </a:r>
+                    </a:p>
+                  </a:txBody>
+                  <a:tcPr/>
+                </a:tc>
+                <a:tc>
+                  <a:txBody>
+                    <a:bodyPr/>
+                    <a:lstStyle/>
+                    <a:p>
+                      <a:r>
+                        <a:rPr sz="1400" b="0">
+                          <a:solidFill>
+                            <a:srgbClr val="1A1A1A"/>
+                          </a:solidFill>
+                        </a:rPr>
+                        <a:t>Não traz na etiqueta</a:t>
+                      </a:r>
+                    </a:p>
+                  </a:txBody>
+                  <a:tcPr/>
+                </a:tc>
+              </a:tr>
+              <a:tr h="502920">
+                <a:tc>
+                  <a:txBody>
+                    <a:bodyPr/>
+                    <a:lstStyle/>
+                    <a:p>
+                      <a:r>
+                        <a:rPr sz="1400" b="0">
+                          <a:solidFill>
+                            <a:srgbClr val="1A1A1A"/>
+                          </a:solidFill>
+                        </a:rPr>
+                        <a:t>Identidade pro provedor</a:t>
+                      </a:r>
+                    </a:p>
+                  </a:txBody>
+                  <a:tcPr/>
+                </a:tc>
+                <a:tc>
+                  <a:txBody>
+                    <a:bodyPr/>
+                    <a:lstStyle/>
+                    <a:p>
+                      <a:r>
+                        <a:rPr sz="1400" b="0">
+                          <a:solidFill>
+                            <a:srgbClr val="1A1A1A"/>
+                          </a:solidFill>
+                        </a:rPr>
+                        <a:t>GPON SN: FHTT…</a:t>
+                      </a:r>
+                    </a:p>
+                  </a:txBody>
+                  <a:tcPr/>
+                </a:tc>
+                <a:tc>
+                  <a:txBody>
+                    <a:bodyPr/>
+                    <a:lstStyle/>
+                    <a:p>
+                      <a:r>
+                        <a:rPr sz="1400" b="0">
+                          <a:solidFill>
+                            <a:srgbClr val="1A1A1A"/>
+                          </a:solidFill>
+                        </a:rPr>
+                        <a:t>S/N: FHTT…</a:t>
+                      </a:r>
+                    </a:p>
+                  </a:txBody>
+                  <a:tcPr/>
+                </a:tc>
+              </a:tr>
+            </a:tbl>
+          </a:graphicData>
+        </a:graphic>
+      </p:graphicFrame>
+      <p:sp>
+        <p:nvSpPr>
+          <p:cNvPr id="7" name="TextBox 6"/>
+          <p:cNvSpPr txBox="1"/>
+          <p:nvPr/>
+        </p:nvSpPr>
+        <p:spPr>
+          <a:xfrm>
+            <a:off x="640080" y="5257800"/>
+            <a:ext cx="10881360" cy="1005840"/>
+          </a:xfrm>
+          <a:prstGeom prst="rect">
+            <a:avLst/>
+          </a:prstGeom>
+          <a:noFill/>
+        </p:spPr>
+        <p:txBody>
+          <a:bodyPr wrap="square" lIns="0" rIns="0" tIns="0" bIns="0" anchor="t">
+            <a:spAutoFit/>
+          </a:bodyPr>
+          <a:lstStyle/>
+          <a:p>
+            <a:pPr algn="ctr"/>
+            <a:r>
+              <a:rPr sz="1400" b="1" i="0">
+                <a:solidFill>
+                  <a:srgbClr val="E88B1A"/>
+                </a:solidFill>
+              </a:rPr>
+              <a:t>Sem Wi-Fi? O cliente precisa de um roteador ligado depois da ONU.</a:t>
+            </a:r>
+          </a:p>
+          <a:p>
+            <a:pPr algn="ctr"/>
+            <a:r>
+              <a:rPr sz="1400" b="1" i="0">
+                <a:solidFill>
+                  <a:srgbClr val="E88B1A"/>
+                </a:solidFill>
+              </a:rPr>
+              <a:t>Fonte 12V 1,5A liga os dois. A de 1A no HG6143D: falta corrente.</a:t>
+            </a:r>
+          </a:p>
+          <a:p>
+            <a:pPr algn="ctr"/>
+            <a:r>
+              <a:rPr sz="1400" b="1" i="0">
+                <a:solidFill>
+                  <a:srgbClr val="E88B1A"/>
+                </a:solidFill>
+              </a:rPr>
+              <a:t>Trocou a ONU? O provedor precisa do número de série novo pra liberar a internet.</a:t>
+            </a:r>
+          </a:p>
+        </p:txBody>
+      </p:sp>
+      <p:sp>
+        <p:nvSpPr>
+          <p:cNvPr id="8" name="TextBox 7"/>
+          <p:cNvSpPr txBox="1"/>
+          <p:nvPr/>
+        </p:nvSpPr>
+        <p:spPr>
+          <a:xfrm>
+            <a:off x="640080" y="6446520"/>
+            <a:ext cx="10881360" cy="274320"/>
+          </a:xfrm>
+          <a:prstGeom prst="rect">
+            <a:avLst/>
+          </a:prstGeom>
+          <a:noFill/>
+        </p:spPr>
+        <p:txBody>
+          <a:bodyPr wrap="square" lIns="0" rIns="0" tIns="0" bIns="0" anchor="t">
+            <a:spAutoFit/>
+          </a:bodyPr>
+          <a:lstStyle/>
+          <a:p>
+            <a:pPr algn="l"/>
+            <a:r>
+              <a:rPr sz="1000" b="0" i="1">
+                <a:solidFill>
+                  <a:srgbClr val="555555"/>
+                </a:solidFill>
+              </a:rPr>
+              <a:t>Redes de Computadores · Noite 2</a:t>
+            </a:r>
+          </a:p>
+        </p:txBody>
+      </p:sp>
+    </p:spTree>
+  </p:cSld>
+  <p:clrMapOvr>
+    <a:masterClrMapping/>
+  </p:clrMapOvr>
+</p:sld>
+</file>
+
+<file path=ppt/slides/slide22.xml><?xml version="1.0" encoding="utf-8"?>
+<p:sld xmlns:a="http://schemas.openxmlformats.org/drawingml/2006/main" xmlns:p="http://schemas.openxmlformats.org/presentationml/2006/main" xmlns:r="http://schemas.openxmlformats.org/officeDocument/2006/relationships">
+  <p:cSld>
+    <p:spTree>
+      <p:nvGrpSpPr>
+        <p:cNvPr id="1" name=""/>
+        <p:cNvGrpSpPr/>
+        <p:nvPr/>
+      </p:nvGrpSpPr>
+      <p:grpSpPr/>
+      <p:sp>
+        <p:nvSpPr>
+          <p:cNvPr id="2" name="Rectangle 1"/>
+          <p:cNvSpPr/>
+          <p:nvPr/>
+        </p:nvSpPr>
+        <p:spPr>
+          <a:xfrm>
+            <a:off x="0" y="0"/>
+            <a:ext cx="12191695" cy="6858000"/>
+          </a:xfrm>
+          <a:prstGeom prst="rect">
+            <a:avLst/>
+          </a:prstGeom>
+          <a:solidFill>
+            <a:srgbClr val="F4F7F7"/>
+          </a:solidFill>
+          <a:ln>
+            <a:noFill/>
+          </a:ln>
+        </p:spPr>
+        <p:style>
+          <a:lnRef idx="1">
+            <a:schemeClr val="accent1"/>
+          </a:lnRef>
+          <a:fillRef idx="3">
+            <a:schemeClr val="accent1"/>
+          </a:fillRef>
+          <a:effectRef idx="2">
+            <a:schemeClr val="accent1"/>
+          </a:effectRef>
+          <a:fontRef idx="minor">
+            <a:schemeClr val="lt1"/>
+          </a:fontRef>
+        </p:style>
+        <p:txBody>
+          <a:bodyPr rtlCol="0" anchor="ctr"/>
+          <a:lstStyle/>
+          <a:p>
+            <a:pPr algn="ctr"/>
+          </a:p>
+        </p:txBody>
+      </p:sp>
+      <p:sp>
+        <p:nvSpPr>
+          <p:cNvPr id="3" name="TextBox 2"/>
+          <p:cNvSpPr txBox="1"/>
+          <p:nvPr/>
+        </p:nvSpPr>
+        <p:spPr>
+          <a:xfrm>
+            <a:off x="640080" y="365760"/>
+            <a:ext cx="10881360" cy="320040"/>
+          </a:xfrm>
+          <a:prstGeom prst="rect">
+            <a:avLst/>
+          </a:prstGeom>
+          <a:noFill/>
+        </p:spPr>
+        <p:txBody>
+          <a:bodyPr wrap="square" lIns="0" rIns="0" tIns="0" bIns="0" anchor="t">
+            <a:spAutoFit/>
+          </a:bodyPr>
+          <a:lstStyle/>
+          <a:p>
+            <a:pPr algn="l"/>
+            <a:r>
+              <a:rPr sz="1300" b="1" i="0">
+                <a:solidFill>
+                  <a:srgbClr val="E88B1A"/>
+                </a:solidFill>
+              </a:rPr>
+              <a:t>CONFERINDO A FICHA</a:t>
+            </a:r>
+          </a:p>
+        </p:txBody>
+      </p:sp>
+      <p:sp>
+        <p:nvSpPr>
+          <p:cNvPr id="4" name="TextBox 3"/>
+          <p:cNvSpPr txBox="1"/>
+          <p:nvPr/>
+        </p:nvSpPr>
+        <p:spPr>
+          <a:xfrm>
+            <a:off x="640080" y="685800"/>
+            <a:ext cx="10881360" cy="822960"/>
+          </a:xfrm>
+          <a:prstGeom prst="rect">
+            <a:avLst/>
+          </a:prstGeom>
+          <a:noFill/>
+        </p:spPr>
+        <p:txBody>
+          <a:bodyPr wrap="square" lIns="0" rIns="0" tIns="0" bIns="0" anchor="t">
+            <a:spAutoFit/>
+          </a:bodyPr>
+          <a:lstStyle/>
+          <a:p>
+            <a:pPr algn="l"/>
+            <a:r>
+              <a:rPr sz="3400" b="1" i="0">
+                <a:solidFill>
+                  <a:srgbClr val="0B5C5C"/>
+                </a:solidFill>
+              </a:rPr>
               <a:t>Cat5e × Cat6</a:t>
             </a:r>
           </a:p>
@@ -9778,345 +10409,6 @@
 </p:sld>
 </file>
 
-<file path=ppt/slides/slide22.xml><?xml version="1.0" encoding="utf-8"?>
-<p:sld xmlns:a="http://schemas.openxmlformats.org/drawingml/2006/main" xmlns:p="http://schemas.openxmlformats.org/presentationml/2006/main" xmlns:r="http://schemas.openxmlformats.org/officeDocument/2006/relationships">
-  <p:cSld>
-    <p:spTree>
-      <p:nvGrpSpPr>
-        <p:cNvPr id="1" name=""/>
-        <p:cNvGrpSpPr/>
-        <p:nvPr/>
-      </p:nvGrpSpPr>
-      <p:grpSpPr/>
-      <p:sp>
-        <p:nvSpPr>
-          <p:cNvPr id="2" name="Rectangle 1"/>
-          <p:cNvSpPr/>
-          <p:nvPr/>
-        </p:nvSpPr>
-        <p:spPr>
-          <a:xfrm>
-            <a:off x="0" y="0"/>
-            <a:ext cx="12191695" cy="6858000"/>
-          </a:xfrm>
-          <a:prstGeom prst="rect">
-            <a:avLst/>
-          </a:prstGeom>
-          <a:solidFill>
-            <a:srgbClr val="F4F7F7"/>
-          </a:solidFill>
-          <a:ln>
-            <a:noFill/>
-          </a:ln>
-        </p:spPr>
-        <p:style>
-          <a:lnRef idx="1">
-            <a:schemeClr val="accent1"/>
-          </a:lnRef>
-          <a:fillRef idx="3">
-            <a:schemeClr val="accent1"/>
-          </a:fillRef>
-          <a:effectRef idx="2">
-            <a:schemeClr val="accent1"/>
-          </a:effectRef>
-          <a:fontRef idx="minor">
-            <a:schemeClr val="lt1"/>
-          </a:fontRef>
-        </p:style>
-        <p:txBody>
-          <a:bodyPr rtlCol="0" anchor="ctr"/>
-          <a:lstStyle/>
-          <a:p>
-            <a:pPr algn="ctr"/>
-          </a:p>
-        </p:txBody>
-      </p:sp>
-      <p:sp>
-        <p:nvSpPr>
-          <p:cNvPr id="3" name="TextBox 2"/>
-          <p:cNvSpPr txBox="1"/>
-          <p:nvPr/>
-        </p:nvSpPr>
-        <p:spPr>
-          <a:xfrm>
-            <a:off x="640080" y="365760"/>
-            <a:ext cx="10881360" cy="320040"/>
-          </a:xfrm>
-          <a:prstGeom prst="rect">
-            <a:avLst/>
-          </a:prstGeom>
-          <a:noFill/>
-        </p:spPr>
-        <p:txBody>
-          <a:bodyPr wrap="square" lIns="0" rIns="0" tIns="0" bIns="0" anchor="t">
-            <a:spAutoFit/>
-          </a:bodyPr>
-          <a:lstStyle/>
-          <a:p>
-            <a:pPr algn="l"/>
-            <a:r>
-              <a:rPr sz="1300" b="1" i="0">
-                <a:solidFill>
-                  <a:srgbClr val="E88B1A"/>
-                </a:solidFill>
-              </a:rPr>
-              <a:t>PRÁTICA · 30 MIN</a:t>
-            </a:r>
-          </a:p>
-        </p:txBody>
-      </p:sp>
-      <p:sp>
-        <p:nvSpPr>
-          <p:cNvPr id="4" name="TextBox 3"/>
-          <p:cNvSpPr txBox="1"/>
-          <p:nvPr/>
-        </p:nvSpPr>
-        <p:spPr>
-          <a:xfrm>
-            <a:off x="640080" y="685800"/>
-            <a:ext cx="10881360" cy="822960"/>
-          </a:xfrm>
-          <a:prstGeom prst="rect">
-            <a:avLst/>
-          </a:prstGeom>
-          <a:noFill/>
-        </p:spPr>
-        <p:txBody>
-          <a:bodyPr wrap="square" lIns="0" rIns="0" tIns="0" bIns="0" anchor="t">
-            <a:spAutoFit/>
-          </a:bodyPr>
-          <a:lstStyle/>
-          <a:p>
-            <a:pPr algn="l"/>
-            <a:r>
-              <a:rPr sz="3400" b="1" i="0">
-                <a:solidFill>
-                  <a:srgbClr val="0B5C5C"/>
-                </a:solidFill>
-              </a:rPr>
-              <a:t>Role-play: Cliente × Técnico</a:t>
-            </a:r>
-          </a:p>
-        </p:txBody>
-      </p:sp>
-      <p:sp>
-        <p:nvSpPr>
-          <p:cNvPr id="5" name="Rectangle 4"/>
-          <p:cNvSpPr/>
-          <p:nvPr/>
-        </p:nvSpPr>
-        <p:spPr>
-          <a:xfrm>
-            <a:off x="640080" y="1554480"/>
-            <a:ext cx="10881360" cy="54864"/>
-          </a:xfrm>
-          <a:prstGeom prst="rect">
-            <a:avLst/>
-          </a:prstGeom>
-          <a:solidFill>
-            <a:srgbClr val="0B5C5C"/>
-          </a:solidFill>
-          <a:ln>
-            <a:noFill/>
-          </a:ln>
-        </p:spPr>
-        <p:style>
-          <a:lnRef idx="1">
-            <a:schemeClr val="accent1"/>
-          </a:lnRef>
-          <a:fillRef idx="3">
-            <a:schemeClr val="accent1"/>
-          </a:fillRef>
-          <a:effectRef idx="2">
-            <a:schemeClr val="accent1"/>
-          </a:effectRef>
-          <a:fontRef idx="minor">
-            <a:schemeClr val="lt1"/>
-          </a:fontRef>
-        </p:style>
-        <p:txBody>
-          <a:bodyPr rtlCol="0" anchor="ctr"/>
-          <a:lstStyle/>
-          <a:p>
-            <a:pPr algn="ctr"/>
-          </a:p>
-        </p:txBody>
-      </p:sp>
-      <p:sp>
-        <p:nvSpPr>
-          <p:cNvPr id="6" name="TextBox 5"/>
-          <p:cNvSpPr txBox="1"/>
-          <p:nvPr/>
-        </p:nvSpPr>
-        <p:spPr>
-          <a:xfrm>
-            <a:off x="640080" y="2560320"/>
-            <a:ext cx="10881360" cy="3840480"/>
-          </a:xfrm>
-          <a:prstGeom prst="rect">
-            <a:avLst/>
-          </a:prstGeom>
-          <a:noFill/>
-        </p:spPr>
-        <p:txBody>
-          <a:bodyPr wrap="square" lIns="0" rIns="0" tIns="0" bIns="0" anchor="t">
-            <a:spAutoFit/>
-          </a:bodyPr>
-          <a:lstStyle/>
-          <a:p>
-            <a:pPr algn="l"/>
-            <a:r>
-              <a:rPr sz="1500" b="0" i="0">
-                <a:solidFill>
-                  <a:srgbClr val="1A1A1A"/>
-                </a:solidFill>
-              </a:rPr>
-              <a:t>Duplas. Um é o cliente, outro é o técnico.</a:t>
-            </a:r>
-          </a:p>
-          <a:p>
-            <a:pPr algn="l"/>
-            <a:r>
-              <a:rPr sz="1500" b="0" i="0">
-                <a:solidFill>
-                  <a:srgbClr val="1A1A1A"/>
-                </a:solidFill>
-              </a:rPr>
-              <a:t/>
-            </a:r>
-          </a:p>
-          <a:p>
-            <a:pPr algn="l"/>
-            <a:r>
-              <a:rPr sz="1500" b="0" i="0">
-                <a:solidFill>
-                  <a:srgbClr val="1A1A1A"/>
-                </a:solidFill>
-              </a:rPr>
-              <a:t>•  Dupla recebe um cartão de chamado (o técnico NÃO vê)</a:t>
-            </a:r>
-          </a:p>
-          <a:p>
-            <a:pPr algn="l"/>
-            <a:r>
-              <a:rPr sz="1500" b="0" i="0">
-                <a:solidFill>
-                  <a:srgbClr val="1A1A1A"/>
-                </a:solidFill>
-              </a:rPr>
-              <a:t>•  Cliente lê e representa o cliente de verdade — sem vocabulário técnico</a:t>
-            </a:r>
-          </a:p>
-          <a:p>
-            <a:pPr algn="l"/>
-            <a:r>
-              <a:rPr sz="1500" b="0" i="0">
-                <a:solidFill>
-                  <a:srgbClr val="1A1A1A"/>
-                </a:solidFill>
-              </a:rPr>
-              <a:t>•  Técnico faz 3-4 perguntas, aponta o equipamento com problema</a:t>
-            </a:r>
-          </a:p>
-          <a:p>
-            <a:pPr algn="l"/>
-            <a:r>
-              <a:rPr sz="1500" b="0" i="0">
-                <a:solidFill>
-                  <a:srgbClr val="1A1A1A"/>
-                </a:solidFill>
-              </a:rPr>
-              <a:t>     e diz o que investigaria primeiro</a:t>
-            </a:r>
-          </a:p>
-          <a:p>
-            <a:pPr algn="l"/>
-            <a:r>
-              <a:rPr sz="1500" b="0" i="0">
-                <a:solidFill>
-                  <a:srgbClr val="1A1A1A"/>
-                </a:solidFill>
-              </a:rPr>
-              <a:t/>
-            </a:r>
-          </a:p>
-          <a:p>
-            <a:pPr algn="l"/>
-            <a:r>
-              <a:rPr sz="1500" b="0" i="0">
-                <a:solidFill>
-                  <a:srgbClr val="1A1A1A"/>
-                </a:solidFill>
-              </a:rPr>
-              <a:t>•  Depois: troca de papéis, novo cartão</a:t>
-            </a:r>
-          </a:p>
-          <a:p>
-            <a:pPr algn="l"/>
-            <a:r>
-              <a:rPr sz="1500" b="0" i="0">
-                <a:solidFill>
-                  <a:srgbClr val="1A1A1A"/>
-                </a:solidFill>
-              </a:rPr>
-              <a:t/>
-            </a:r>
-          </a:p>
-          <a:p>
-            <a:pPr algn="l"/>
-            <a:r>
-              <a:rPr sz="1500" b="0" i="0">
-                <a:solidFill>
-                  <a:srgbClr val="1A1A1A"/>
-                </a:solidFill>
-              </a:rPr>
-              <a:t>•  Discussão coletiva: 3 duplas contam qual foi o chamado</a:t>
-            </a:r>
-          </a:p>
-        </p:txBody>
-      </p:sp>
-      <p:sp>
-        <p:nvSpPr>
-          <p:cNvPr id="7" name="TextBox 6"/>
-          <p:cNvSpPr txBox="1"/>
-          <p:nvPr/>
-        </p:nvSpPr>
-        <p:spPr>
-          <a:xfrm>
-            <a:off x="640080" y="6446520"/>
-            <a:ext cx="10881360" cy="274320"/>
-          </a:xfrm>
-          <a:prstGeom prst="rect">
-            <a:avLst/>
-          </a:prstGeom>
-          <a:noFill/>
-        </p:spPr>
-        <p:txBody>
-          <a:bodyPr wrap="square" lIns="0" rIns="0" tIns="0" bIns="0" anchor="t">
-            <a:spAutoFit/>
-          </a:bodyPr>
-          <a:lstStyle/>
-          <a:p>
-            <a:pPr algn="l"/>
-            <a:r>
-              <a:rPr sz="1000" b="0" i="1">
-                <a:solidFill>
-                  <a:srgbClr val="555555"/>
-                </a:solidFill>
-              </a:rPr>
-              <a:t>Redes de Computadores · Noite 2</a:t>
-            </a:r>
-          </a:p>
-        </p:txBody>
-      </p:sp>
-    </p:spTree>
-  </p:cSld>
-  <p:clrMapOvr>
-    <a:masterClrMapping/>
-  </p:clrMapOvr>
-</p:sld>
-</file>
-
 <file path=ppt/slides/slide23.xml><?xml version="1.0" encoding="utf-8"?>
 <p:sld xmlns:a="http://schemas.openxmlformats.org/drawingml/2006/main" xmlns:p="http://schemas.openxmlformats.org/presentationml/2006/main" xmlns:r="http://schemas.openxmlformats.org/officeDocument/2006/relationships">
   <p:cSld>
@@ -10199,7 +10491,7 @@
                   <a:srgbClr val="E88B1A"/>
                 </a:solidFill>
               </a:rPr>
-              <a:t>O MÉTODO</a:t>
+              <a:t>PRÁTICA · 30 MIN</a:t>
             </a:r>
           </a:p>
         </p:txBody>
@@ -10233,7 +10525,7 @@
                   <a:srgbClr val="0B5C5C"/>
                 </a:solidFill>
               </a:rPr>
-              <a:t>O que o técnico verifica ao chegar</a:t>
+              <a:t>Role-play: Cliente × Técnico</a:t>
             </a:r>
           </a:p>
         </p:txBody>
@@ -10290,82 +10582,126 @@
         <p:spPr>
           <a:xfrm>
             <a:off x="640080" y="2560320"/>
-            <a:ext cx="10881360" cy="3657600"/>
-          </a:xfrm>
-          <a:prstGeom prst="rect">
-            <a:avLst/>
-          </a:prstGeom>
-          <a:noFill/>
-        </p:spPr>
-        <p:txBody>
-          <a:bodyPr wrap="square" lIns="0" rIns="0" tIns="0" bIns="0" anchor="t">
-            <a:spAutoFit/>
-          </a:bodyPr>
-          <a:lstStyle/>
-          <a:p>
-            <a:pPr algn="l"/>
-            <a:r>
-              <a:rPr sz="1400" b="0" i="0">
+            <a:ext cx="10881360" cy="3840480"/>
+          </a:xfrm>
+          <a:prstGeom prst="rect">
+            <a:avLst/>
+          </a:prstGeom>
+          <a:noFill/>
+        </p:spPr>
+        <p:txBody>
+          <a:bodyPr wrap="square" lIns="0" rIns="0" tIns="0" bIns="0" anchor="t">
+            <a:spAutoFit/>
+          </a:bodyPr>
+          <a:lstStyle/>
+          <a:p>
+            <a:pPr algn="l"/>
+            <a:r>
+              <a:rPr sz="1500" b="0" i="0">
                 <a:solidFill>
                   <a:srgbClr val="1A1A1A"/>
                 </a:solidFill>
               </a:rPr>
-              <a:t>1.  A luz de fibra ou internet está acesa? Se não, o problema é antes do roteador</a:t>
-            </a:r>
-          </a:p>
-          <a:p>
-            <a:pPr algn="l"/>
-            <a:r>
-              <a:rPr sz="1400" b="0" i="0">
+              <a:t>Duplas. Um é o cliente, outro é o técnico.</a:t>
+            </a:r>
+          </a:p>
+          <a:p>
+            <a:pPr algn="l"/>
+            <a:r>
+              <a:rPr sz="1500" b="0" i="0">
                 <a:solidFill>
                   <a:srgbClr val="1A1A1A"/>
                 </a:solidFill>
               </a:rPr>
-              <a:t>2.  Os cabos estão firmes, com clique? Cabo meio solto é campeão de chamado</a:t>
-            </a:r>
-          </a:p>
-          <a:p>
-            <a:pPr algn="l"/>
-            <a:r>
-              <a:rPr sz="1400" b="0" i="0">
+              <a:t/>
+            </a:r>
+          </a:p>
+          <a:p>
+            <a:pPr algn="l"/>
+            <a:r>
+              <a:rPr sz="1500" b="0" i="0">
                 <a:solidFill>
                   <a:srgbClr val="1A1A1A"/>
                 </a:solidFill>
               </a:rPr>
-              <a:t>3.  O cabo do provedor está na porta WAN, e não numa LAN?</a:t>
-            </a:r>
-          </a:p>
-          <a:p>
-            <a:pPr algn="l"/>
-            <a:r>
-              <a:rPr sz="1400" b="0" i="0">
+              <a:t>•  Dupla recebe um cartão de chamado (o técnico NÃO vê)</a:t>
+            </a:r>
+          </a:p>
+          <a:p>
+            <a:pPr algn="l"/>
+            <a:r>
+              <a:rPr sz="1500" b="0" i="0">
                 <a:solidFill>
                   <a:srgbClr val="1A1A1A"/>
                 </a:solidFill>
               </a:rPr>
-              <a:t>4.  Outro aparelho conecta? Se só um falha, o problema é no aparelho</a:t>
-            </a:r>
-          </a:p>
-          <a:p>
-            <a:pPr algn="l"/>
-            <a:r>
-              <a:rPr sz="1400" b="0" i="0">
+              <a:t>•  Cliente lê e representa o cliente de verdade — sem vocabulário técnico</a:t>
+            </a:r>
+          </a:p>
+          <a:p>
+            <a:pPr algn="l"/>
+            <a:r>
+              <a:rPr sz="1500" b="0" i="0">
                 <a:solidFill>
                   <a:srgbClr val="1A1A1A"/>
                 </a:solidFill>
               </a:rPr>
-              <a:t>5.  Conecta na rede mas não abre página? Aí é sinal do provedor</a:t>
-            </a:r>
-          </a:p>
-          <a:p>
-            <a:pPr algn="l"/>
-            <a:r>
-              <a:rPr sz="1400" b="0" i="0">
+              <a:t>•  Técnico faz 3-4 perguntas, aponta o equipamento com problema</a:t>
+            </a:r>
+          </a:p>
+          <a:p>
+            <a:pPr algn="l"/>
+            <a:r>
+              <a:rPr sz="1500" b="0" i="0">
                 <a:solidFill>
                   <a:srgbClr val="1A1A1A"/>
                 </a:solidFill>
               </a:rPr>
-              <a:t>6.  Desligar da tomada por 10 segundos e ligar resolveu? Registre que resolveu.</a:t>
+              <a:t>     e diz o que investigaria primeiro</a:t>
+            </a:r>
+          </a:p>
+          <a:p>
+            <a:pPr algn="l"/>
+            <a:r>
+              <a:rPr sz="1500" b="0" i="0">
+                <a:solidFill>
+                  <a:srgbClr val="1A1A1A"/>
+                </a:solidFill>
+              </a:rPr>
+              <a:t/>
+            </a:r>
+          </a:p>
+          <a:p>
+            <a:pPr algn="l"/>
+            <a:r>
+              <a:rPr sz="1500" b="0" i="0">
+                <a:solidFill>
+                  <a:srgbClr val="1A1A1A"/>
+                </a:solidFill>
+              </a:rPr>
+              <a:t>•  Depois: troca de papéis, novo cartão</a:t>
+            </a:r>
+          </a:p>
+          <a:p>
+            <a:pPr algn="l"/>
+            <a:r>
+              <a:rPr sz="1500" b="0" i="0">
+                <a:solidFill>
+                  <a:srgbClr val="1A1A1A"/>
+                </a:solidFill>
+              </a:rPr>
+              <a:t/>
+            </a:r>
+          </a:p>
+          <a:p>
+            <a:pPr algn="l"/>
+            <a:r>
+              <a:rPr sz="1500" b="0" i="0">
+                <a:solidFill>
+                  <a:srgbClr val="1A1A1A"/>
+                </a:solidFill>
+              </a:rPr>
+              <a:t>•  Discussão coletiva: 3 duplas contam qual foi o chamado</a:t>
             </a:r>
           </a:p>
         </p:txBody>
@@ -10373,40 +10709,6 @@
       <p:sp>
         <p:nvSpPr>
           <p:cNvPr id="7" name="TextBox 6"/>
-          <p:cNvSpPr txBox="1"/>
-          <p:nvPr/>
-        </p:nvSpPr>
-        <p:spPr>
-          <a:xfrm>
-            <a:off x="640080" y="6126480"/>
-            <a:ext cx="10881360" cy="365760"/>
-          </a:xfrm>
-          <a:prstGeom prst="rect">
-            <a:avLst/>
-          </a:prstGeom>
-          <a:noFill/>
-        </p:spPr>
-        <p:txBody>
-          <a:bodyPr wrap="square" lIns="0" rIns="0" tIns="0" bIns="0" anchor="t">
-            <a:spAutoFit/>
-          </a:bodyPr>
-          <a:lstStyle/>
-          <a:p>
-            <a:pPr algn="ctr"/>
-            <a:r>
-              <a:rPr sz="1400" b="0" i="1">
-                <a:solidFill>
-                  <a:srgbClr val="555555"/>
-                </a:solidFill>
-              </a:rPr>
-              <a:t>Sempre na mesma ordem. Método evita retrabalho e troca desnecessária.</a:t>
-            </a:r>
-          </a:p>
-        </p:txBody>
-      </p:sp>
-      <p:sp>
-        <p:nvSpPr>
-          <p:cNvPr id="8" name="TextBox 7"/>
           <p:cNvSpPr txBox="1"/>
           <p:nvPr/>
         </p:nvSpPr>
@@ -10528,7 +10830,7 @@
                   <a:srgbClr val="E88B1A"/>
                 </a:solidFill>
               </a:rPr>
-              <a:t>ENCENAR UM CHAMADO</a:t>
+              <a:t>O MÉTODO</a:t>
             </a:r>
           </a:p>
         </p:txBody>
@@ -10562,7 +10864,7 @@
                   <a:srgbClr val="0B5C5C"/>
                 </a:solidFill>
               </a:rPr>
-              <a:t>Cliente × Técnico ao vivo, turma inteira assiste</a:t>
+              <a:t>O que o técnico verifica ao chegar</a:t>
             </a:r>
           </a:p>
         </p:txBody>
@@ -10619,115 +10921,82 @@
         <p:spPr>
           <a:xfrm>
             <a:off x="640080" y="2560320"/>
-            <a:ext cx="10881360" cy="3840480"/>
-          </a:xfrm>
-          <a:prstGeom prst="rect">
-            <a:avLst/>
-          </a:prstGeom>
-          <a:noFill/>
-        </p:spPr>
-        <p:txBody>
-          <a:bodyPr wrap="square" lIns="0" rIns="0" tIns="0" bIns="0" anchor="t">
-            <a:spAutoFit/>
-          </a:bodyPr>
-          <a:lstStyle/>
-          <a:p>
-            <a:pPr algn="l"/>
-            <a:r>
-              <a:rPr sz="1500" b="0" i="0">
+            <a:ext cx="10881360" cy="3657600"/>
+          </a:xfrm>
+          <a:prstGeom prst="rect">
+            <a:avLst/>
+          </a:prstGeom>
+          <a:noFill/>
+        </p:spPr>
+        <p:txBody>
+          <a:bodyPr wrap="square" lIns="0" rIns="0" tIns="0" bIns="0" anchor="t">
+            <a:spAutoFit/>
+          </a:bodyPr>
+          <a:lstStyle/>
+          <a:p>
+            <a:pPr algn="l"/>
+            <a:r>
+              <a:rPr sz="1400" b="0" i="0">
                 <a:solidFill>
                   <a:srgbClr val="1A1A1A"/>
                 </a:solidFill>
               </a:rPr>
-              <a:t>•  Professor escolhe 2 alunos: 1 cliente, 1 técnico</a:t>
-            </a:r>
-          </a:p>
-          <a:p>
-            <a:pPr algn="l"/>
-            <a:r>
-              <a:rPr sz="1500" b="0" i="0">
+              <a:t>1.  A luz de fibra ou internet está acesa? Se não, o problema é antes do roteador</a:t>
+            </a:r>
+          </a:p>
+          <a:p>
+            <a:pPr algn="l"/>
+            <a:r>
+              <a:rPr sz="1400" b="0" i="0">
                 <a:solidFill>
                   <a:srgbClr val="1A1A1A"/>
                 </a:solidFill>
               </a:rPr>
-              <a:t>•  Professor sussurra o defeito só pro cliente</a:t>
-            </a:r>
-          </a:p>
-          <a:p>
-            <a:pPr algn="l"/>
-            <a:r>
-              <a:rPr sz="1500" b="0" i="0">
+              <a:t>2.  Os cabos estão firmes, com clique? Cabo meio solto é campeão de chamado</a:t>
+            </a:r>
+          </a:p>
+          <a:p>
+            <a:pPr algn="l"/>
+            <a:r>
+              <a:rPr sz="1400" b="0" i="0">
                 <a:solidFill>
                   <a:srgbClr val="1A1A1A"/>
                 </a:solidFill>
               </a:rPr>
-              <a:t>•  Técnico faz perguntas na ordem do método</a:t>
-            </a:r>
-          </a:p>
-          <a:p>
-            <a:pPr algn="l"/>
-            <a:r>
-              <a:rPr sz="1500" b="0" i="0">
+              <a:t>3.  O cabo do provedor está na porta WAN, e não numa LAN?</a:t>
+            </a:r>
+          </a:p>
+          <a:p>
+            <a:pPr algn="l"/>
+            <a:r>
+              <a:rPr sz="1400" b="0" i="0">
                 <a:solidFill>
                   <a:srgbClr val="1A1A1A"/>
                 </a:solidFill>
               </a:rPr>
-              <a:t>•  Turma assiste e ajuda quando o técnico trava</a:t>
-            </a:r>
-          </a:p>
-          <a:p>
-            <a:pPr algn="l"/>
-            <a:r>
-              <a:rPr sz="1500" b="0" i="0">
+              <a:t>4.  Outro aparelho conecta? Se só um falha, o problema é no aparelho</a:t>
+            </a:r>
+          </a:p>
+          <a:p>
+            <a:pPr algn="l"/>
+            <a:r>
+              <a:rPr sz="1400" b="0" i="0">
                 <a:solidFill>
                   <a:srgbClr val="1A1A1A"/>
                 </a:solidFill>
               </a:rPr>
-              <a:t/>
-            </a:r>
-          </a:p>
-          <a:p>
-            <a:pPr algn="l"/>
-            <a:r>
-              <a:rPr sz="1500" b="0" i="0">
+              <a:t>5.  Conecta na rede mas não abre página? Aí é sinal do provedor</a:t>
+            </a:r>
+          </a:p>
+          <a:p>
+            <a:pPr algn="l"/>
+            <a:r>
+              <a:rPr sz="1400" b="0" i="0">
                 <a:solidFill>
                   <a:srgbClr val="1A1A1A"/>
                 </a:solidFill>
               </a:rPr>
-              <a:t>Defeitos que rolam bem:</a:t>
-            </a:r>
-          </a:p>
-          <a:p>
-            <a:pPr algn="l"/>
-            <a:r>
-              <a:rPr sz="1500" b="0" i="0">
-                <a:solidFill>
-                  <a:srgbClr val="1A1A1A"/>
-                </a:solidFill>
-              </a:rPr>
-              <a:t>     •  Cabo do provedor na porta LAN 3</a:t>
-            </a:r>
-          </a:p>
-          <a:p>
-            <a:pPr algn="l"/>
-            <a:r>
-              <a:rPr sz="1500" b="0" i="0">
-                <a:solidFill>
-                  <a:srgbClr val="1A1A1A"/>
-                </a:solidFill>
-              </a:rPr>
-              <a:t>     •  Cabo do computador solto no roteador</a:t>
-            </a:r>
-          </a:p>
-          <a:p>
-            <a:pPr algn="l"/>
-            <a:r>
-              <a:rPr sz="1500" b="0" i="0">
-                <a:solidFill>
-                  <a:srgbClr val="1A1A1A"/>
-                </a:solidFill>
-              </a:rPr>
-              <a:t>     •  Roteador foi resetado e perdeu configuração</a:t>
+              <a:t>6.  Desligar da tomada por 10 segundos e ligar resolveu? Registre que resolveu.</a:t>
             </a:r>
           </a:p>
         </p:txBody>
@@ -10735,6 +11004,40 @@
       <p:sp>
         <p:nvSpPr>
           <p:cNvPr id="7" name="TextBox 6"/>
+          <p:cNvSpPr txBox="1"/>
+          <p:nvPr/>
+        </p:nvSpPr>
+        <p:spPr>
+          <a:xfrm>
+            <a:off x="640080" y="6126480"/>
+            <a:ext cx="10881360" cy="365760"/>
+          </a:xfrm>
+          <a:prstGeom prst="rect">
+            <a:avLst/>
+          </a:prstGeom>
+          <a:noFill/>
+        </p:spPr>
+        <p:txBody>
+          <a:bodyPr wrap="square" lIns="0" rIns="0" tIns="0" bIns="0" anchor="t">
+            <a:spAutoFit/>
+          </a:bodyPr>
+          <a:lstStyle/>
+          <a:p>
+            <a:pPr algn="ctr"/>
+            <a:r>
+              <a:rPr sz="1400" b="0" i="1">
+                <a:solidFill>
+                  <a:srgbClr val="555555"/>
+                </a:solidFill>
+              </a:rPr>
+              <a:t>Sempre na mesma ordem. Método evita retrabalho e troca desnecessária.</a:t>
+            </a:r>
+          </a:p>
+        </p:txBody>
+      </p:sp>
+      <p:sp>
+        <p:nvSpPr>
+          <p:cNvPr id="8" name="TextBox 7"/>
           <p:cNvSpPr txBox="1"/>
           <p:nvPr/>
         </p:nvSpPr>
@@ -10856,7 +11159,7 @@
                   <a:srgbClr val="E88B1A"/>
                 </a:solidFill>
               </a:rPr>
-              <a:t>DUELO RELÂMPAGO · 15 MIN</a:t>
+              <a:t>ENCENAR UM CHAMADO</a:t>
             </a:r>
           </a:p>
         </p:txBody>
@@ -10890,7 +11193,7 @@
                   <a:srgbClr val="0B5C5C"/>
                 </a:solidFill>
               </a:rPr>
-              <a:t>Time A × Time B</a:t>
+              <a:t>Cliente × Técnico ao vivo, turma inteira assiste</a:t>
             </a:r>
           </a:p>
         </p:txBody>
@@ -10962,100 +11265,100 @@
           <a:p>
             <a:pPr algn="l"/>
             <a:r>
-              <a:rPr sz="1700" b="0" i="0">
+              <a:rPr sz="1500" b="0" i="0">
                 <a:solidFill>
                   <a:srgbClr val="1A1A1A"/>
                 </a:solidFill>
               </a:rPr>
-              <a:t>As perguntas de hoje giram em torno de:</a:t>
-            </a:r>
-          </a:p>
-          <a:p>
-            <a:pPr algn="l"/>
-            <a:r>
-              <a:rPr sz="1700" b="0" i="0">
+              <a:t>•  Professor escolhe 2 alunos: 1 cliente, 1 técnico</a:t>
+            </a:r>
+          </a:p>
+          <a:p>
+            <a:pPr algn="l"/>
+            <a:r>
+              <a:rPr sz="1500" b="0" i="0">
                 <a:solidFill>
                   <a:srgbClr val="1A1A1A"/>
                 </a:solidFill>
               </a:rPr>
+              <a:t>•  Professor sussurra o defeito só pro cliente</a:t>
+            </a:r>
+          </a:p>
+          <a:p>
+            <a:pPr algn="l"/>
+            <a:r>
+              <a:rPr sz="1500" b="0" i="0">
+                <a:solidFill>
+                  <a:srgbClr val="1A1A1A"/>
+                </a:solidFill>
+              </a:rPr>
+              <a:t>•  Técnico faz perguntas na ordem do método</a:t>
+            </a:r>
+          </a:p>
+          <a:p>
+            <a:pPr algn="l"/>
+            <a:r>
+              <a:rPr sz="1500" b="0" i="0">
+                <a:solidFill>
+                  <a:srgbClr val="1A1A1A"/>
+                </a:solidFill>
+              </a:rPr>
+              <a:t>•  Turma assiste e ajuda quando o técnico trava</a:t>
+            </a:r>
+          </a:p>
+          <a:p>
+            <a:pPr algn="l"/>
+            <a:r>
+              <a:rPr sz="1500" b="0" i="0">
+                <a:solidFill>
+                  <a:srgbClr val="1A1A1A"/>
+                </a:solidFill>
+              </a:rPr>
               <a:t/>
             </a:r>
           </a:p>
           <a:p>
             <a:pPr algn="l"/>
             <a:r>
-              <a:rPr sz="1700" b="0" i="0">
+              <a:rPr sz="1500" b="0" i="0">
                 <a:solidFill>
                   <a:srgbClr val="1A1A1A"/>
                 </a:solidFill>
               </a:rPr>
-              <a:t>     •  Diferença entre os 5 equipamentos</a:t>
-            </a:r>
-          </a:p>
-          <a:p>
-            <a:pPr algn="l"/>
-            <a:r>
-              <a:rPr sz="1700" b="0" i="0">
+              <a:t>Defeitos que rolam bem:</a:t>
+            </a:r>
+          </a:p>
+          <a:p>
+            <a:pPr algn="l"/>
+            <a:r>
+              <a:rPr sz="1500" b="0" i="0">
                 <a:solidFill>
                   <a:srgbClr val="1A1A1A"/>
                 </a:solidFill>
               </a:rPr>
-              <a:t>     •  Reconhecer a porta WAN</a:t>
-            </a:r>
-          </a:p>
-          <a:p>
-            <a:pPr algn="l"/>
-            <a:r>
-              <a:rPr sz="1700" b="0" i="0">
+              <a:t>     •  Cabo do provedor na porta LAN 3</a:t>
+            </a:r>
+          </a:p>
+          <a:p>
+            <a:pPr algn="l"/>
+            <a:r>
+              <a:rPr sz="1500" b="0" i="0">
                 <a:solidFill>
                   <a:srgbClr val="1A1A1A"/>
                 </a:solidFill>
               </a:rPr>
-              <a:t>     •  Ler as luzes do painel</a:t>
-            </a:r>
-          </a:p>
-          <a:p>
-            <a:pPr algn="l"/>
-            <a:r>
-              <a:rPr sz="1700" b="0" i="0">
+              <a:t>     •  Cabo do computador solto no roteador</a:t>
+            </a:r>
+          </a:p>
+          <a:p>
+            <a:pPr algn="l"/>
+            <a:r>
+              <a:rPr sz="1500" b="0" i="0">
                 <a:solidFill>
                   <a:srgbClr val="1A1A1A"/>
                 </a:solidFill>
               </a:rPr>
-              <a:t>     •  Etapas 1-3 × etapas 4-6</a:t>
-            </a:r>
-          </a:p>
-          <a:p>
-            <a:pPr algn="l"/>
-            <a:r>
-              <a:rPr sz="1700" b="0" i="0">
-                <a:solidFill>
-                  <a:srgbClr val="1A1A1A"/>
-                </a:solidFill>
-              </a:rPr>
-              <a:t>     •  Cenários de chamado</a:t>
-            </a:r>
-          </a:p>
-          <a:p>
-            <a:pPr algn="l"/>
-            <a:r>
-              <a:rPr sz="1700" b="0" i="0">
-                <a:solidFill>
-                  <a:srgbClr val="1A1A1A"/>
-                </a:solidFill>
-              </a:rPr>
-              <a:t/>
-            </a:r>
-          </a:p>
-          <a:p>
-            <a:pPr algn="l"/>
-            <a:r>
-              <a:rPr sz="1700" b="0" i="0">
-                <a:solidFill>
-                  <a:srgbClr val="1A1A1A"/>
-                </a:solidFill>
-              </a:rPr>
-              <a:t>Resposta em 5 segundos. Alterna entre times.</a:t>
+              <a:t>     •  Roteador foi resetado e perdeu configuração</a:t>
             </a:r>
           </a:p>
         </p:txBody>
@@ -11184,7 +11487,7 @@
                   <a:srgbClr val="E88B1A"/>
                 </a:solidFill>
               </a:rPr>
-              <a:t>O RESUMO DA NOITE</a:t>
+              <a:t>DUELO RELÂMPAGO · 15 MIN</a:t>
             </a:r>
           </a:p>
         </p:txBody>
@@ -11218,7 +11521,7 @@
                   <a:srgbClr val="0B5C5C"/>
                 </a:solidFill>
               </a:rPr>
-              <a:t>Não tem internet dentro da caixinha</a:t>
+              <a:t>Time A × Time B</a:t>
             </a:r>
           </a:p>
         </p:txBody>
@@ -11274,34 +11577,34 @@
         </p:nvSpPr>
         <p:spPr>
           <a:xfrm>
-            <a:off x="640080" y="2743200"/>
-            <a:ext cx="10881360" cy="3200400"/>
-          </a:xfrm>
-          <a:prstGeom prst="rect">
-            <a:avLst/>
-          </a:prstGeom>
-          <a:noFill/>
-        </p:spPr>
-        <p:txBody>
-          <a:bodyPr wrap="square" lIns="0" rIns="0" tIns="0" bIns="0" anchor="t">
-            <a:spAutoFit/>
-          </a:bodyPr>
-          <a:lstStyle/>
-          <a:p>
-            <a:pPr algn="l"/>
-            <a:r>
-              <a:rPr sz="2000" b="0" i="0">
+            <a:off x="640080" y="2560320"/>
+            <a:ext cx="10881360" cy="3840480"/>
+          </a:xfrm>
+          <a:prstGeom prst="rect">
+            <a:avLst/>
+          </a:prstGeom>
+          <a:noFill/>
+        </p:spPr>
+        <p:txBody>
+          <a:bodyPr wrap="square" lIns="0" rIns="0" tIns="0" bIns="0" anchor="t">
+            <a:spAutoFit/>
+          </a:bodyPr>
+          <a:lstStyle/>
+          <a:p>
+            <a:pPr algn="l"/>
+            <a:r>
+              <a:rPr sz="1700" b="0" i="0">
                 <a:solidFill>
                   <a:srgbClr val="1A1A1A"/>
                 </a:solidFill>
               </a:rPr>
-              <a:t>•  Ela é só a ponta de um caminho que começa do outro lado do mundo.</a:t>
-            </a:r>
-          </a:p>
-          <a:p>
-            <a:pPr algn="l"/>
-            <a:r>
-              <a:rPr sz="2000" b="0" i="0">
+              <a:t>As perguntas de hoje giram em torno de:</a:t>
+            </a:r>
+          </a:p>
+          <a:p>
+            <a:pPr algn="l"/>
+            <a:r>
+              <a:rPr sz="1700" b="0" i="0">
                 <a:solidFill>
                   <a:srgbClr val="1A1A1A"/>
                 </a:solidFill>
@@ -11312,34 +11615,78 @@
           <a:p>
             <a:pPr algn="l"/>
             <a:r>
-              <a:rPr sz="2000" b="0" i="0">
+              <a:rPr sz="1700" b="0" i="0">
                 <a:solidFill>
                   <a:srgbClr val="1A1A1A"/>
                 </a:solidFill>
               </a:rPr>
-              <a:t>•  Seu trabalho começa no poste da rua e termina na tela do cliente.</a:t>
-            </a:r>
-          </a:p>
-          <a:p>
-            <a:pPr algn="l"/>
-            <a:r>
-              <a:rPr sz="2000" b="0" i="0">
+              <a:t>     •  Diferença entre os 5 equipamentos</a:t>
+            </a:r>
+          </a:p>
+          <a:p>
+            <a:pPr algn="l"/>
+            <a:r>
+              <a:rPr sz="1700" b="0" i="0">
                 <a:solidFill>
                   <a:srgbClr val="1A1A1A"/>
                 </a:solidFill>
               </a:rPr>
+              <a:t>     •  Reconhecer a porta WAN</a:t>
+            </a:r>
+          </a:p>
+          <a:p>
+            <a:pPr algn="l"/>
+            <a:r>
+              <a:rPr sz="1700" b="0" i="0">
+                <a:solidFill>
+                  <a:srgbClr val="1A1A1A"/>
+                </a:solidFill>
+              </a:rPr>
+              <a:t>     •  Ler as luzes do painel</a:t>
+            </a:r>
+          </a:p>
+          <a:p>
+            <a:pPr algn="l"/>
+            <a:r>
+              <a:rPr sz="1700" b="0" i="0">
+                <a:solidFill>
+                  <a:srgbClr val="1A1A1A"/>
+                </a:solidFill>
+              </a:rPr>
+              <a:t>     •  Etapas 1-3 × etapas 4-6</a:t>
+            </a:r>
+          </a:p>
+          <a:p>
+            <a:pPr algn="l"/>
+            <a:r>
+              <a:rPr sz="1700" b="0" i="0">
+                <a:solidFill>
+                  <a:srgbClr val="1A1A1A"/>
+                </a:solidFill>
+              </a:rPr>
+              <a:t>     •  Cenários de chamado</a:t>
+            </a:r>
+          </a:p>
+          <a:p>
+            <a:pPr algn="l"/>
+            <a:r>
+              <a:rPr sz="1700" b="0" i="0">
+                <a:solidFill>
+                  <a:srgbClr val="1A1A1A"/>
+                </a:solidFill>
+              </a:rPr>
               <a:t/>
             </a:r>
           </a:p>
           <a:p>
             <a:pPr algn="l"/>
             <a:r>
-              <a:rPr sz="2000" b="0" i="0">
+              <a:rPr sz="1700" b="0" i="0">
                 <a:solidFill>
                   <a:srgbClr val="1A1A1A"/>
                 </a:solidFill>
               </a:rPr>
-              <a:t>•  Tudo que vem antes disso é com o provedor.</a:t>
+              <a:t>Resposta em 5 segundos. Alterna entre times.</a:t>
             </a:r>
           </a:p>
         </p:txBody>
@@ -11468,7 +11815,7 @@
                   <a:srgbClr val="E88B1A"/>
                 </a:solidFill>
               </a:rPr>
-              <a:t>FECHANDO</a:t>
+              <a:t>O RESUMO DA NOITE</a:t>
             </a:r>
           </a:p>
         </p:txBody>
@@ -11502,7 +11849,7 @@
                   <a:srgbClr val="0B5C5C"/>
                 </a:solidFill>
               </a:rPr>
-              <a:t>Seis perguntas para conferir</a:t>
+              <a:t>Não tem internet dentro da caixinha</a:t>
             </a:r>
           </a:p>
         </p:txBody>
@@ -11558,83 +11905,72 @@
         </p:nvSpPr>
         <p:spPr>
           <a:xfrm>
-            <a:off x="640080" y="2560320"/>
-            <a:ext cx="10881360" cy="3657600"/>
-          </a:xfrm>
-          <a:prstGeom prst="rect">
-            <a:avLst/>
-          </a:prstGeom>
-          <a:noFill/>
-        </p:spPr>
-        <p:txBody>
-          <a:bodyPr wrap="square" lIns="0" rIns="0" tIns="0" bIns="0" anchor="t">
-            <a:spAutoFit/>
-          </a:bodyPr>
-          <a:lstStyle/>
-          <a:p>
-            <a:pPr algn="l"/>
-            <a:r>
-              <a:rPr sz="1600" b="0" i="0">
+            <a:off x="640080" y="2743200"/>
+            <a:ext cx="10881360" cy="3200400"/>
+          </a:xfrm>
+          <a:prstGeom prst="rect">
+            <a:avLst/>
+          </a:prstGeom>
+          <a:noFill/>
+        </p:spPr>
+        <p:txBody>
+          <a:bodyPr wrap="square" lIns="0" rIns="0" tIns="0" bIns="0" anchor="t">
+            <a:spAutoFit/>
+          </a:bodyPr>
+          <a:lstStyle/>
+          <a:p>
+            <a:pPr algn="l"/>
+            <a:r>
+              <a:rPr sz="2000" b="0" i="0">
                 <a:solidFill>
                   <a:srgbClr val="1A1A1A"/>
                 </a:solidFill>
               </a:rPr>
-              <a:t>1.  Qual é a diferença entre modem e roteador?</a:t>
-            </a:r>
-          </a:p>
-          <a:p>
-            <a:pPr algn="l"/>
-            <a:r>
-              <a:rPr sz="1600" b="0" i="0">
+              <a:t>•  Ela é só a ponta de um caminho que começa do outro lado do mundo.</a:t>
+            </a:r>
+          </a:p>
+          <a:p>
+            <a:pPr algn="l"/>
+            <a:r>
+              <a:rPr sz="2000" b="0" i="0">
                 <a:solidFill>
                   <a:srgbClr val="1A1A1A"/>
                 </a:solidFill>
               </a:rPr>
-              <a:t>2.  O switch cria rede? O que ele faz então?</a:t>
-            </a:r>
-          </a:p>
-          <a:p>
-            <a:pPr algn="l"/>
-            <a:r>
-              <a:rPr sz="1600" b="0" i="0">
+              <a:t/>
+            </a:r>
+          </a:p>
+          <a:p>
+            <a:pPr algn="l"/>
+            <a:r>
+              <a:rPr sz="2000" b="0" i="0">
                 <a:solidFill>
                   <a:srgbClr val="1A1A1A"/>
                 </a:solidFill>
               </a:rPr>
-              <a:t>3.  Como você reconhece a porta WAN num roteador que nunca viu?</a:t>
-            </a:r>
-          </a:p>
-          <a:p>
-            <a:pPr algn="l"/>
-            <a:r>
-              <a:rPr sz="1600" b="0" i="0">
+              <a:t>•  Seu trabalho começa no poste da rua e termina na tela do cliente.</a:t>
+            </a:r>
+          </a:p>
+          <a:p>
+            <a:pPr algn="l"/>
+            <a:r>
+              <a:rPr sz="2000" b="0" i="0">
                 <a:solidFill>
                   <a:srgbClr val="1A1A1A"/>
                 </a:solidFill>
               </a:rPr>
-              <a:t>4.  O que acontece se o cabo do provedor for ligado numa porta LAN?</a:t>
-            </a:r>
-          </a:p>
-          <a:p>
-            <a:pPr algn="l"/>
-            <a:r>
-              <a:rPr sz="1600" b="0" i="0">
+              <a:t/>
+            </a:r>
+          </a:p>
+          <a:p>
+            <a:pPr algn="l"/>
+            <a:r>
+              <a:rPr sz="2000" b="0" i="0">
                 <a:solidFill>
                   <a:srgbClr val="1A1A1A"/>
                 </a:solidFill>
               </a:rPr>
-              <a:t>5.  Por que o Wi-Fi do quarto costuma ser pior que o da sala?</a:t>
-            </a:r>
-          </a:p>
-          <a:p>
-            <a:pPr algn="l"/>
-            <a:r>
-              <a:rPr sz="1600" b="0" i="0">
-                <a:solidFill>
-                  <a:srgbClr val="1A1A1A"/>
-                </a:solidFill>
-              </a:rPr>
-              <a:t>6.  A luz de fibra está apagada. Onde está o problema?</a:t>
+              <a:t>•  Tudo que vem antes disso é com o provedor.</a:t>
             </a:r>
           </a:p>
         </p:txBody>
@@ -11763,7 +12099,7 @@
                   <a:srgbClr val="E88B1A"/>
                 </a:solidFill>
               </a:rPr>
-              <a:t>O QUE FICA DESTA NOITE</a:t>
+              <a:t>FECHANDO</a:t>
             </a:r>
           </a:p>
         </p:txBody>
@@ -11797,7 +12133,7 @@
                   <a:srgbClr val="0B5C5C"/>
                 </a:solidFill>
               </a:rPr>
-              <a:t>Cinco coisas para levar</a:t>
+              <a:t>Seis perguntas para conferir</a:t>
             </a:r>
           </a:p>
         </p:txBody>
@@ -11853,72 +12189,83 @@
         </p:nvSpPr>
         <p:spPr>
           <a:xfrm>
-            <a:off x="640080" y="2743200"/>
-            <a:ext cx="10881360" cy="3200400"/>
-          </a:xfrm>
-          <a:prstGeom prst="rect">
-            <a:avLst/>
-          </a:prstGeom>
-          <a:noFill/>
-        </p:spPr>
-        <p:txBody>
-          <a:bodyPr wrap="square" lIns="0" rIns="0" tIns="0" bIns="0" anchor="t">
-            <a:spAutoFit/>
-          </a:bodyPr>
-          <a:lstStyle/>
-          <a:p>
-            <a:pPr algn="l"/>
-            <a:r>
-              <a:rPr sz="1700" b="0" i="0">
+            <a:off x="640080" y="2560320"/>
+            <a:ext cx="10881360" cy="3657600"/>
+          </a:xfrm>
+          <a:prstGeom prst="rect">
+            <a:avLst/>
+          </a:prstGeom>
+          <a:noFill/>
+        </p:spPr>
+        <p:txBody>
+          <a:bodyPr wrap="square" lIns="0" rIns="0" tIns="0" bIns="0" anchor="t">
+            <a:spAutoFit/>
+          </a:bodyPr>
+          <a:lstStyle/>
+          <a:p>
+            <a:pPr algn="l"/>
+            <a:r>
+              <a:rPr sz="1600" b="0" i="0">
                 <a:solidFill>
                   <a:srgbClr val="1A1A1A"/>
                 </a:solidFill>
               </a:rPr>
-              <a:t>•  A internet vem de longe e passa por seis etapas até você</a:t>
-            </a:r>
-          </a:p>
-          <a:p>
-            <a:pPr algn="l"/>
-            <a:r>
-              <a:rPr sz="1700" b="0" i="0">
+              <a:t>1.  Qual é a diferença entre modem e roteador?</a:t>
+            </a:r>
+          </a:p>
+          <a:p>
+            <a:pPr algn="l"/>
+            <a:r>
+              <a:rPr sz="1600" b="0" i="0">
                 <a:solidFill>
                   <a:srgbClr val="1A1A1A"/>
                 </a:solidFill>
               </a:rPr>
-              <a:t>•  Só o roteador cria rede — os outros ajudam</a:t>
-            </a:r>
-          </a:p>
-          <a:p>
-            <a:pPr algn="l"/>
-            <a:r>
-              <a:rPr sz="1700" b="0" i="0">
+              <a:t>2.  O switch cria rede? O que ele faz então?</a:t>
+            </a:r>
+          </a:p>
+          <a:p>
+            <a:pPr algn="l"/>
+            <a:r>
+              <a:rPr sz="1600" b="0" i="0">
                 <a:solidFill>
                   <a:srgbClr val="1A1A1A"/>
                 </a:solidFill>
               </a:rPr>
-              <a:t>•  A porta WAN é diferente, e trocar ela é o erro mais comum</a:t>
-            </a:r>
-          </a:p>
-          <a:p>
-            <a:pPr algn="l"/>
-            <a:r>
-              <a:rPr sz="1700" b="0" i="0">
+              <a:t>3.  Como você reconhece a porta WAN num roteador que nunca viu?</a:t>
+            </a:r>
+          </a:p>
+          <a:p>
+            <a:pPr algn="l"/>
+            <a:r>
+              <a:rPr sz="1600" b="0" i="0">
                 <a:solidFill>
                   <a:srgbClr val="1A1A1A"/>
                 </a:solidFill>
               </a:rPr>
-              <a:t>•  A etiqueta embaixo tem tudo que o suporte vai pedir</a:t>
-            </a:r>
-          </a:p>
-          <a:p>
-            <a:pPr algn="l"/>
-            <a:r>
-              <a:rPr sz="1700" b="0" i="0">
+              <a:t>4.  O que acontece se o cabo do provedor for ligado numa porta LAN?</a:t>
+            </a:r>
+          </a:p>
+          <a:p>
+            <a:pPr algn="l"/>
+            <a:r>
+              <a:rPr sz="1600" b="0" i="0">
                 <a:solidFill>
                   <a:srgbClr val="1A1A1A"/>
                 </a:solidFill>
               </a:rPr>
-              <a:t>•  As luzes do painel dizem onde está o problema antes de você abrir nada</a:t>
+              <a:t>5.  Por que o Wi-Fi do quarto costuma ser pior que o da sala?</a:t>
+            </a:r>
+          </a:p>
+          <a:p>
+            <a:pPr algn="l"/>
+            <a:r>
+              <a:rPr sz="1600" b="0" i="0">
+                <a:solidFill>
+                  <a:srgbClr val="1A1A1A"/>
+                </a:solidFill>
+              </a:rPr>
+              <a:t>6.  A luz de fibra está apagada. Onde está o problema?</a:t>
             </a:r>
           </a:p>
         </p:txBody>
@@ -12047,7 +12394,7 @@
                   <a:srgbClr val="E88B1A"/>
                 </a:solidFill>
               </a:rPr>
-              <a:t>PARA A PRÓXIMA NOITE</a:t>
+              <a:t>O QUE FICA DESTA NOITE</a:t>
             </a:r>
           </a:p>
         </p:txBody>
@@ -12081,7 +12428,7 @@
                   <a:srgbClr val="0B5C5C"/>
                 </a:solidFill>
               </a:rPr>
-              <a:t>Por onde o sinal viaja</a:t>
+              <a:t>Cinco coisas para levar</a:t>
             </a:r>
           </a:p>
         </p:txBody>
@@ -12137,105 +12484,72 @@
         </p:nvSpPr>
         <p:spPr>
           <a:xfrm>
-            <a:off x="640080" y="2560320"/>
-            <a:ext cx="10881360" cy="3840480"/>
-          </a:xfrm>
-          <a:prstGeom prst="rect">
-            <a:avLst/>
-          </a:prstGeom>
-          <a:noFill/>
-        </p:spPr>
-        <p:txBody>
-          <a:bodyPr wrap="square" lIns="0" rIns="0" tIns="0" bIns="0" anchor="t">
-            <a:spAutoFit/>
-          </a:bodyPr>
-          <a:lstStyle/>
-          <a:p>
-            <a:pPr algn="l"/>
-            <a:r>
-              <a:rPr sz="1500" b="0" i="0">
+            <a:off x="640080" y="2743200"/>
+            <a:ext cx="10881360" cy="3200400"/>
+          </a:xfrm>
+          <a:prstGeom prst="rect">
+            <a:avLst/>
+          </a:prstGeom>
+          <a:noFill/>
+        </p:spPr>
+        <p:txBody>
+          <a:bodyPr wrap="square" lIns="0" rIns="0" tIns="0" bIns="0" anchor="t">
+            <a:spAutoFit/>
+          </a:bodyPr>
+          <a:lstStyle/>
+          <a:p>
+            <a:pPr algn="l"/>
+            <a:r>
+              <a:rPr sz="1700" b="0" i="0">
                 <a:solidFill>
                   <a:srgbClr val="1A1A1A"/>
                 </a:solidFill>
               </a:rPr>
-              <a:t>Uma tarefa simples:</a:t>
-            </a:r>
-          </a:p>
-          <a:p>
-            <a:pPr algn="l"/>
-            <a:r>
-              <a:rPr sz="1500" b="0" i="0">
+              <a:t>•  A internet vem de longe e passa por seis etapas até você</a:t>
+            </a:r>
+          </a:p>
+          <a:p>
+            <a:pPr algn="l"/>
+            <a:r>
+              <a:rPr sz="1700" b="0" i="0">
                 <a:solidFill>
                   <a:srgbClr val="1A1A1A"/>
                 </a:solidFill>
               </a:rPr>
-              <a:t/>
-            </a:r>
-          </a:p>
-          <a:p>
-            <a:pPr algn="l"/>
-            <a:r>
-              <a:rPr sz="1500" b="0" i="0">
+              <a:t>•  Só o roteador cria rede — os outros ajudam</a:t>
+            </a:r>
+          </a:p>
+          <a:p>
+            <a:pPr algn="l"/>
+            <a:r>
+              <a:rPr sz="1700" b="0" i="0">
                 <a:solidFill>
                   <a:srgbClr val="1A1A1A"/>
                 </a:solidFill>
               </a:rPr>
-              <a:t>•  Ler a etiqueta do roteador da sua casa</a:t>
-            </a:r>
-          </a:p>
-          <a:p>
-            <a:pPr algn="l"/>
-            <a:r>
-              <a:rPr sz="1500" b="0" i="0">
+              <a:t>•  A porta WAN é diferente, e trocar ela é o erro mais comum</a:t>
+            </a:r>
+          </a:p>
+          <a:p>
+            <a:pPr algn="l"/>
+            <a:r>
+              <a:rPr sz="1700" b="0" i="0">
                 <a:solidFill>
                   <a:srgbClr val="1A1A1A"/>
                 </a:solidFill>
               </a:rPr>
-              <a:t>•  Anotar marca, modelo, velocidade do Wi-Fi e se é Dual Band (senha NÃO)</a:t>
-            </a:r>
-          </a:p>
-          <a:p>
-            <a:pPr algn="l"/>
-            <a:r>
-              <a:rPr sz="1500" b="0" i="0">
+              <a:t>•  A etiqueta embaixo tem tudo que o suporte vai pedir</a:t>
+            </a:r>
+          </a:p>
+          <a:p>
+            <a:pPr algn="l"/>
+            <a:r>
+              <a:rPr sz="1700" b="0" i="0">
                 <a:solidFill>
                   <a:srgbClr val="1A1A1A"/>
                 </a:solidFill>
               </a:rPr>
-              <a:t>•  Senha não se anota nem se fotografa — tampe com o dedo</a:t>
-            </a:r>
-          </a:p>
-          <a:p>
-            <a:pPr algn="l"/>
-            <a:r>
-              <a:rPr sz="1500" b="0" i="0">
-                <a:solidFill>
-                  <a:srgbClr val="1A1A1A"/>
-                </a:solidFill>
-              </a:rPr>
-              <a:t>•  Trazer anotado — vamos comparar os aparelhos da turma</a:t>
-            </a:r>
-          </a:p>
-          <a:p>
-            <a:pPr algn="l"/>
-            <a:r>
-              <a:rPr sz="1500" b="0" i="0">
-                <a:solidFill>
-                  <a:srgbClr val="1A1A1A"/>
-                </a:solidFill>
-              </a:rPr>
-              <a:t/>
-            </a:r>
-          </a:p>
-          <a:p>
-            <a:pPr algn="l"/>
-            <a:r>
-              <a:rPr sz="1500" b="0" i="0">
-                <a:solidFill>
-                  <a:srgbClr val="1A1A1A"/>
-                </a:solidFill>
-              </a:rPr>
-              <a:t>Quem não tem roteador em casa: olhe o de um parente ou vizinho.</a:t>
+              <a:t>•  As luzes do painel dizem onde está o problema antes de você abrir nada</a:t>
             </a:r>
           </a:p>
         </p:txBody>
@@ -12595,6 +12909,323 @@
       <p:sp>
         <p:nvSpPr>
           <p:cNvPr id="9" name="TextBox 8"/>
+          <p:cNvSpPr txBox="1"/>
+          <p:nvPr/>
+        </p:nvSpPr>
+        <p:spPr>
+          <a:xfrm>
+            <a:off x="640080" y="6446520"/>
+            <a:ext cx="10881360" cy="274320"/>
+          </a:xfrm>
+          <a:prstGeom prst="rect">
+            <a:avLst/>
+          </a:prstGeom>
+          <a:noFill/>
+        </p:spPr>
+        <p:txBody>
+          <a:bodyPr wrap="square" lIns="0" rIns="0" tIns="0" bIns="0" anchor="t">
+            <a:spAutoFit/>
+          </a:bodyPr>
+          <a:lstStyle/>
+          <a:p>
+            <a:pPr algn="l"/>
+            <a:r>
+              <a:rPr sz="1000" b="0" i="1">
+                <a:solidFill>
+                  <a:srgbClr val="555555"/>
+                </a:solidFill>
+              </a:rPr>
+              <a:t>Redes de Computadores · Noite 2</a:t>
+            </a:r>
+          </a:p>
+        </p:txBody>
+      </p:sp>
+    </p:spTree>
+  </p:cSld>
+  <p:clrMapOvr>
+    <a:masterClrMapping/>
+  </p:clrMapOvr>
+</p:sld>
+</file>
+
+<file path=ppt/slides/slide30.xml><?xml version="1.0" encoding="utf-8"?>
+<p:sld xmlns:a="http://schemas.openxmlformats.org/drawingml/2006/main" xmlns:p="http://schemas.openxmlformats.org/presentationml/2006/main" xmlns:r="http://schemas.openxmlformats.org/officeDocument/2006/relationships">
+  <p:cSld>
+    <p:spTree>
+      <p:nvGrpSpPr>
+        <p:cNvPr id="1" name=""/>
+        <p:cNvGrpSpPr/>
+        <p:nvPr/>
+      </p:nvGrpSpPr>
+      <p:grpSpPr/>
+      <p:sp>
+        <p:nvSpPr>
+          <p:cNvPr id="2" name="Rectangle 1"/>
+          <p:cNvSpPr/>
+          <p:nvPr/>
+        </p:nvSpPr>
+        <p:spPr>
+          <a:xfrm>
+            <a:off x="0" y="0"/>
+            <a:ext cx="12191695" cy="6858000"/>
+          </a:xfrm>
+          <a:prstGeom prst="rect">
+            <a:avLst/>
+          </a:prstGeom>
+          <a:solidFill>
+            <a:srgbClr val="F4F7F7"/>
+          </a:solidFill>
+          <a:ln>
+            <a:noFill/>
+          </a:ln>
+        </p:spPr>
+        <p:style>
+          <a:lnRef idx="1">
+            <a:schemeClr val="accent1"/>
+          </a:lnRef>
+          <a:fillRef idx="3">
+            <a:schemeClr val="accent1"/>
+          </a:fillRef>
+          <a:effectRef idx="2">
+            <a:schemeClr val="accent1"/>
+          </a:effectRef>
+          <a:fontRef idx="minor">
+            <a:schemeClr val="lt1"/>
+          </a:fontRef>
+        </p:style>
+        <p:txBody>
+          <a:bodyPr rtlCol="0" anchor="ctr"/>
+          <a:lstStyle/>
+          <a:p>
+            <a:pPr algn="ctr"/>
+          </a:p>
+        </p:txBody>
+      </p:sp>
+      <p:sp>
+        <p:nvSpPr>
+          <p:cNvPr id="3" name="TextBox 2"/>
+          <p:cNvSpPr txBox="1"/>
+          <p:nvPr/>
+        </p:nvSpPr>
+        <p:spPr>
+          <a:xfrm>
+            <a:off x="640080" y="365760"/>
+            <a:ext cx="10881360" cy="320040"/>
+          </a:xfrm>
+          <a:prstGeom prst="rect">
+            <a:avLst/>
+          </a:prstGeom>
+          <a:noFill/>
+        </p:spPr>
+        <p:txBody>
+          <a:bodyPr wrap="square" lIns="0" rIns="0" tIns="0" bIns="0" anchor="t">
+            <a:spAutoFit/>
+          </a:bodyPr>
+          <a:lstStyle/>
+          <a:p>
+            <a:pPr algn="l"/>
+            <a:r>
+              <a:rPr sz="1300" b="1" i="0">
+                <a:solidFill>
+                  <a:srgbClr val="E88B1A"/>
+                </a:solidFill>
+              </a:rPr>
+              <a:t>PARA A PRÓXIMA NOITE</a:t>
+            </a:r>
+          </a:p>
+        </p:txBody>
+      </p:sp>
+      <p:sp>
+        <p:nvSpPr>
+          <p:cNvPr id="4" name="TextBox 3"/>
+          <p:cNvSpPr txBox="1"/>
+          <p:nvPr/>
+        </p:nvSpPr>
+        <p:spPr>
+          <a:xfrm>
+            <a:off x="640080" y="685800"/>
+            <a:ext cx="10881360" cy="822960"/>
+          </a:xfrm>
+          <a:prstGeom prst="rect">
+            <a:avLst/>
+          </a:prstGeom>
+          <a:noFill/>
+        </p:spPr>
+        <p:txBody>
+          <a:bodyPr wrap="square" lIns="0" rIns="0" tIns="0" bIns="0" anchor="t">
+            <a:spAutoFit/>
+          </a:bodyPr>
+          <a:lstStyle/>
+          <a:p>
+            <a:pPr algn="l"/>
+            <a:r>
+              <a:rPr sz="3400" b="1" i="0">
+                <a:solidFill>
+                  <a:srgbClr val="0B5C5C"/>
+                </a:solidFill>
+              </a:rPr>
+              <a:t>Por onde o sinal viaja</a:t>
+            </a:r>
+          </a:p>
+        </p:txBody>
+      </p:sp>
+      <p:sp>
+        <p:nvSpPr>
+          <p:cNvPr id="5" name="Rectangle 4"/>
+          <p:cNvSpPr/>
+          <p:nvPr/>
+        </p:nvSpPr>
+        <p:spPr>
+          <a:xfrm>
+            <a:off x="640080" y="1554480"/>
+            <a:ext cx="10881360" cy="54864"/>
+          </a:xfrm>
+          <a:prstGeom prst="rect">
+            <a:avLst/>
+          </a:prstGeom>
+          <a:solidFill>
+            <a:srgbClr val="0B5C5C"/>
+          </a:solidFill>
+          <a:ln>
+            <a:noFill/>
+          </a:ln>
+        </p:spPr>
+        <p:style>
+          <a:lnRef idx="1">
+            <a:schemeClr val="accent1"/>
+          </a:lnRef>
+          <a:fillRef idx="3">
+            <a:schemeClr val="accent1"/>
+          </a:fillRef>
+          <a:effectRef idx="2">
+            <a:schemeClr val="accent1"/>
+          </a:effectRef>
+          <a:fontRef idx="minor">
+            <a:schemeClr val="lt1"/>
+          </a:fontRef>
+        </p:style>
+        <p:txBody>
+          <a:bodyPr rtlCol="0" anchor="ctr"/>
+          <a:lstStyle/>
+          <a:p>
+            <a:pPr algn="ctr"/>
+          </a:p>
+        </p:txBody>
+      </p:sp>
+      <p:sp>
+        <p:nvSpPr>
+          <p:cNvPr id="6" name="TextBox 5"/>
+          <p:cNvSpPr txBox="1"/>
+          <p:nvPr/>
+        </p:nvSpPr>
+        <p:spPr>
+          <a:xfrm>
+            <a:off x="640080" y="2560320"/>
+            <a:ext cx="10881360" cy="3840480"/>
+          </a:xfrm>
+          <a:prstGeom prst="rect">
+            <a:avLst/>
+          </a:prstGeom>
+          <a:noFill/>
+        </p:spPr>
+        <p:txBody>
+          <a:bodyPr wrap="square" lIns="0" rIns="0" tIns="0" bIns="0" anchor="t">
+            <a:spAutoFit/>
+          </a:bodyPr>
+          <a:lstStyle/>
+          <a:p>
+            <a:pPr algn="l"/>
+            <a:r>
+              <a:rPr sz="1500" b="0" i="0">
+                <a:solidFill>
+                  <a:srgbClr val="1A1A1A"/>
+                </a:solidFill>
+              </a:rPr>
+              <a:t>Uma tarefa simples:</a:t>
+            </a:r>
+          </a:p>
+          <a:p>
+            <a:pPr algn="l"/>
+            <a:r>
+              <a:rPr sz="1500" b="0" i="0">
+                <a:solidFill>
+                  <a:srgbClr val="1A1A1A"/>
+                </a:solidFill>
+              </a:rPr>
+              <a:t/>
+            </a:r>
+          </a:p>
+          <a:p>
+            <a:pPr algn="l"/>
+            <a:r>
+              <a:rPr sz="1500" b="0" i="0">
+                <a:solidFill>
+                  <a:srgbClr val="1A1A1A"/>
+                </a:solidFill>
+              </a:rPr>
+              <a:t>•  Ler a etiqueta do roteador da sua casa</a:t>
+            </a:r>
+          </a:p>
+          <a:p>
+            <a:pPr algn="l"/>
+            <a:r>
+              <a:rPr sz="1500" b="0" i="0">
+                <a:solidFill>
+                  <a:srgbClr val="1A1A1A"/>
+                </a:solidFill>
+              </a:rPr>
+              <a:t>•  Anotar marca, modelo, velocidade do Wi-Fi e se é Dual Band (senha NÃO)</a:t>
+            </a:r>
+          </a:p>
+          <a:p>
+            <a:pPr algn="l"/>
+            <a:r>
+              <a:rPr sz="1500" b="0" i="0">
+                <a:solidFill>
+                  <a:srgbClr val="1A1A1A"/>
+                </a:solidFill>
+              </a:rPr>
+              <a:t>•  Senha não se anota nem se fotografa — tampe com o dedo</a:t>
+            </a:r>
+          </a:p>
+          <a:p>
+            <a:pPr algn="l"/>
+            <a:r>
+              <a:rPr sz="1500" b="0" i="0">
+                <a:solidFill>
+                  <a:srgbClr val="1A1A1A"/>
+                </a:solidFill>
+              </a:rPr>
+              <a:t>•  Trazer anotado — vamos comparar os aparelhos da turma</a:t>
+            </a:r>
+          </a:p>
+          <a:p>
+            <a:pPr algn="l"/>
+            <a:r>
+              <a:rPr sz="1500" b="0" i="0">
+                <a:solidFill>
+                  <a:srgbClr val="1A1A1A"/>
+                </a:solidFill>
+              </a:rPr>
+              <a:t/>
+            </a:r>
+          </a:p>
+          <a:p>
+            <a:pPr algn="l"/>
+            <a:r>
+              <a:rPr sz="1500" b="0" i="0">
+                <a:solidFill>
+                  <a:srgbClr val="1A1A1A"/>
+                </a:solidFill>
+              </a:rPr>
+              <a:t>Quem não tem roteador em casa: olhe o de um parente ou vizinho.</a:t>
+            </a:r>
+          </a:p>
+        </p:txBody>
+      </p:sp>
+      <p:sp>
+        <p:nvSpPr>
+          <p:cNvPr id="7" name="TextBox 6"/>
           <p:cNvSpPr txBox="1"/>
           <p:nvPr/>
         </p:nvSpPr>

</xml_diff>

<commit_message>
fix: Noite 2 - folha do aluno na ordem da aula e passos da pratica com pagina
Fichas passam para as paginas 2 a 5 e o role-play vai para a 6.
Cada passo da pratica indica onde anotar; linha de conferencia da troca de bancada.

Co-Authored-By: Claude Opus 5.5 <noreply@anthropic.com>
Claude-Session: https://claude.ai/code/session_015y4tKZEhCyJs3fFMDuZmcy
</commit_message>
<xml_diff>
--- a/Aula - Redes 2 - Como a internet chega.pptx
+++ b/Aula - Redes 2 - Como a internet chega.pptx
@@ -7705,7 +7705,7 @@
                   <a:srgbClr val="1A1A1A"/>
                 </a:solidFill>
               </a:rPr>
-              <a:t>1.  Identificar cada equipamento e dizer o que faz</a:t>
+              <a:t>1.  Identificar cada equipamento e dizer o que faz  →  pág. 1, quadro 2</a:t>
             </a:r>
           </a:p>
           <a:p>
@@ -7716,7 +7716,7 @@
                   <a:srgbClr val="1A1A1A"/>
                 </a:solidFill>
               </a:rPr>
-              <a:t>2.  Achar a porta WAN de cada roteador (e explicar como reconheceu)</a:t>
+              <a:t>2.  Achar a porta WAN de cada roteador e explicar como reconheceu  →  pág. 2 e 3</a:t>
             </a:r>
           </a:p>
           <a:p>
@@ -7727,7 +7727,7 @@
                   <a:srgbClr val="1A1A1A"/>
                 </a:solidFill>
               </a:rPr>
-              <a:t>3.  Contar as portas LAN e anotar</a:t>
+              <a:t>3.  Contar as portas LAN e anotar  →  pág. 2</a:t>
             </a:r>
           </a:p>
           <a:p>
@@ -7738,7 +7738,7 @@
                   <a:srgbClr val="1A1A1A"/>
                 </a:solidFill>
               </a:rPr>
-              <a:t>4.  Ler a etiqueta de dois roteadores e preencher a ficha (páginas 3 e 4)</a:t>
+              <a:t>4.  Ler a etiqueta de dois roteadores e preencher a ficha  →  pág. 2</a:t>
             </a:r>
           </a:p>
           <a:p>
@@ -7749,7 +7749,7 @@
                   <a:srgbClr val="1A1A1A"/>
                 </a:solidFill>
               </a:rPr>
-              <a:t>5.  Ligar o roteador e observar as luzes acendendo</a:t>
+              <a:t>5.  Ligar o roteador e observar as luzes acendendo  →  pág. 3</a:t>
             </a:r>
           </a:p>
           <a:p>
@@ -7760,7 +7760,7 @@
                   <a:srgbClr val="1A1A1A"/>
                 </a:solidFill>
               </a:rPr>
-              <a:t>6.  Ler a etiqueta dos dois modems de fibra (página 5)</a:t>
+              <a:t>6.  Ler a etiqueta dos dois modems de fibra  →  pág. 4</a:t>
             </a:r>
           </a:p>
           <a:p>
@@ -7771,7 +7771,7 @@
                   <a:srgbClr val="1A1A1A"/>
                 </a:solidFill>
               </a:rPr>
-              <a:t>7.  Ler a capa de um cabo Cat5e e de um Cat6 (página 6)</a:t>
+              <a:t>7.  Ler a capa de um cabo Cat5e e de um Cat6  →  pág. 5</a:t>
             </a:r>
           </a:p>
           <a:p>
@@ -7782,7 +7782,7 @@
                   <a:srgbClr val="1A1A1A"/>
                 </a:solidFill>
               </a:rPr>
-              <a:t>8.  Trocar de bancada e conferir o que a outra equipe anotou</a:t>
+              <a:t>8.  Trocar de bancada e conferir o que a outra equipe anotou  →  fim da pág. 5</a:t>
             </a:r>
           </a:p>
         </p:txBody>

</xml_diff>

<commit_message>
fix: Noite 2 - slides de correcao na mesma ordem e numeracao da folha
Pense como tecnico do roteador reordenado (WAN, fonte, 300 Mega) e novo
slide com as 3 respostas do modem de fibra, incluindo onde vai ligado.

Co-Authored-By: Claude Opus 5.5 <noreply@anthropic.com>
Claude-Session: https://claude.ai/code/session_015y4tKZEhCyJs3fFMDuZmcy
</commit_message>
<xml_diff>
--- a/Aula - Redes 2 - Como a internet chega.pptx
+++ b/Aula - Redes 2 - Como a internet chega.pptx
@@ -35,6 +35,7 @@
     <p:sldId id="283" r:id="rId34"/>
     <p:sldId id="284" r:id="rId35"/>
     <p:sldId id="285" r:id="rId36"/>
+    <p:sldId id="286" r:id="rId37"/>
   </p:sldIdLst>
   <p:sldSz cx="12191695" cy="6858000" type="screen4x3"/>
   <p:notesSz cx="6858000" cy="9144000"/>
@@ -8913,7 +8914,7 @@
                   <a:srgbClr val="E88B1A"/>
                 </a:solidFill>
               </a:rPr>
-              <a:t>CONFERINDO A FICHA</a:t>
+              <a:t>CONFERINDO A FICHA · PÁG. 3</a:t>
             </a:r>
           </a:p>
         </p:txBody>
@@ -8947,7 +8948,7 @@
                   <a:srgbClr val="0B5C5C"/>
                 </a:solidFill>
               </a:rPr>
-              <a:t>Pense como técnico</a:t>
+              <a:t>Pense como técnico · roteador</a:t>
             </a:r>
           </a:p>
         </p:txBody>
@@ -9003,8 +9004,8 @@
         </p:nvSpPr>
         <p:spPr>
           <a:xfrm>
-            <a:off x="640080" y="2377440"/>
-            <a:ext cx="10881360" cy="3657600"/>
+            <a:off x="640080" y="2194560"/>
+            <a:ext cx="10881360" cy="3749039"/>
           </a:xfrm>
           <a:prstGeom prst="rect">
             <a:avLst/>
@@ -9024,7 +9025,7 @@
                   <a:srgbClr val="1A1A1A"/>
                 </a:solidFill>
               </a:rPr>
-              <a:t>A fonte de um serve no outro?</a:t>
+              <a:t>1.  Como você reconheceu a porta WAN sem ninguém falar?</a:t>
             </a:r>
           </a:p>
           <a:p>
@@ -9035,7 +9036,7 @@
                   <a:srgbClr val="1A1A1A"/>
                 </a:solidFill>
               </a:rPr>
-              <a:t>  NÃO. Um pede 9V, o outro 12V. Fonte errada pode queimar o aparelho — ou não ligar.</a:t>
+              <a:t>     Separada das outras, de outra cor, escrito WAN ou Internet (ou um globo).</a:t>
             </a:r>
           </a:p>
           <a:p>
@@ -9057,7 +9058,7 @@
                   <a:srgbClr val="1A1A1A"/>
                 </a:solidFill>
               </a:rPr>
-              <a:t>Plano de 300 Mega, computador no cabo: qual indicar?</a:t>
+              <a:t>2.  A fonte de um roteador pode ser usada no outro?</a:t>
             </a:r>
           </a:p>
           <a:p>
@@ -9068,7 +9069,7 @@
                   <a:srgbClr val="1A1A1A"/>
                 </a:solidFill>
               </a:rPr>
-              <a:t>  O Archer C5. As portas do 840N são de 100 Mbps: no cabo, o cliente nunca passa de ~94.</a:t>
+              <a:t>     NÃO. Um pede 9V, o outro 12V. Fonte errada pode queimar o aparelho — ou não ligar.</a:t>
             </a:r>
           </a:p>
           <a:p>
@@ -9090,7 +9091,7 @@
                   <a:srgbClr val="1A1A1A"/>
                 </a:solidFill>
               </a:rPr>
-              <a:t>Como reconhecer a WAN sem ninguém falar?</a:t>
+              <a:t>3.  Plano de 300 Mega, computador no cabo: qual dos dois indicar?</a:t>
             </a:r>
           </a:p>
           <a:p>
@@ -9101,7 +9102,7 @@
                   <a:srgbClr val="1A1A1A"/>
                 </a:solidFill>
               </a:rPr>
-              <a:t>  Separada das outras, de outra cor, escrito WAN ou Internet (ou um globo).</a:t>
+              <a:t>     O Archer C5. As portas do 840N são de 100 Mbps: no cabo, o cliente nunca passa de ~94.</a:t>
             </a:r>
           </a:p>
         </p:txBody>
@@ -9355,8 +9356,8 @@
           <p:nvPr/>
         </p:nvGraphicFramePr>
         <p:xfrm>
-          <a:off x="640080" y="2103120"/>
-          <a:ext cx="10881360" cy="3017520"/>
+          <a:off x="640080" y="2194560"/>
+          <a:ext cx="10881360" cy="3291840"/>
         </p:xfrm>
         <a:graphic>
           <a:graphicData uri="http://schemas.openxmlformats.org/drawingml/2006/table">
@@ -9369,14 +9370,14 @@
                 <a:gridCol w="4023360"/>
                 <a:gridCol w="3566160"/>
               </a:tblGrid>
-              <a:tr h="502920">
+              <a:tr h="548640">
                 <a:tc>
                   <a:txBody>
                     <a:bodyPr/>
                     <a:lstStyle/>
                     <a:p>
                       <a:r>
-                        <a:rPr sz="1400" b="1">
+                        <a:rPr sz="1500" b="1">
                           <a:solidFill>
                             <a:srgbClr val="FFFFFF"/>
                           </a:solidFill>
@@ -9397,7 +9398,7 @@
                     <a:lstStyle/>
                     <a:p>
                       <a:r>
-                        <a:rPr sz="1400" b="1">
+                        <a:rPr sz="1500" b="1">
                           <a:solidFill>
                             <a:srgbClr val="FFFFFF"/>
                           </a:solidFill>
@@ -9418,7 +9419,7 @@
                     <a:lstStyle/>
                     <a:p>
                       <a:r>
-                        <a:rPr sz="1400" b="1">
+                        <a:rPr sz="1500" b="1">
                           <a:solidFill>
                             <a:srgbClr val="FFFFFF"/>
                           </a:solidFill>
@@ -9434,14 +9435,14 @@
                   </a:tcPr>
                 </a:tc>
               </a:tr>
-              <a:tr h="502920">
+              <a:tr h="548640">
                 <a:tc>
                   <a:txBody>
                     <a:bodyPr/>
                     <a:lstStyle/>
                     <a:p>
                       <a:r>
-                        <a:rPr sz="1400" b="0">
+                        <a:rPr sz="1500" b="0">
                           <a:solidFill>
                             <a:srgbClr val="1A1A1A"/>
                           </a:solidFill>
@@ -9458,7 +9459,7 @@
                     <a:lstStyle/>
                     <a:p>
                       <a:r>
-                        <a:rPr sz="1400" b="0">
+                        <a:rPr sz="1500" b="0">
                           <a:solidFill>
                             <a:srgbClr val="1A1A1A"/>
                           </a:solidFill>
@@ -9475,7 +9476,7 @@
                     <a:lstStyle/>
                     <a:p>
                       <a:r>
-                        <a:rPr sz="1400" b="0">
+                        <a:rPr sz="1500" b="0">
                           <a:solidFill>
                             <a:srgbClr val="1A1A1A"/>
                           </a:solidFill>
@@ -9487,14 +9488,14 @@
                   <a:tcPr/>
                 </a:tc>
               </a:tr>
-              <a:tr h="502920">
+              <a:tr h="548640">
                 <a:tc>
                   <a:txBody>
                     <a:bodyPr/>
                     <a:lstStyle/>
                     <a:p>
                       <a:r>
-                        <a:rPr sz="1400" b="0">
+                        <a:rPr sz="1500" b="0">
                           <a:solidFill>
                             <a:srgbClr val="1A1A1A"/>
                           </a:solidFill>
@@ -9511,7 +9512,7 @@
                     <a:lstStyle/>
                     <a:p>
                       <a:r>
-                        <a:rPr sz="1400" b="0">
+                        <a:rPr sz="1500" b="0">
                           <a:solidFill>
                             <a:srgbClr val="1A1A1A"/>
                           </a:solidFill>
@@ -9528,7 +9529,7 @@
                     <a:lstStyle/>
                     <a:p>
                       <a:r>
-                        <a:rPr sz="1400" b="0">
+                        <a:rPr sz="1500" b="0">
                           <a:solidFill>
                             <a:srgbClr val="1A1A1A"/>
                           </a:solidFill>
@@ -9540,14 +9541,14 @@
                   <a:tcPr/>
                 </a:tc>
               </a:tr>
-              <a:tr h="502920">
+              <a:tr h="548640">
                 <a:tc>
                   <a:txBody>
                     <a:bodyPr/>
                     <a:lstStyle/>
                     <a:p>
                       <a:r>
-                        <a:rPr sz="1400" b="0">
+                        <a:rPr sz="1500" b="0">
                           <a:solidFill>
                             <a:srgbClr val="1A1A1A"/>
                           </a:solidFill>
@@ -9564,7 +9565,7 @@
                     <a:lstStyle/>
                     <a:p>
                       <a:r>
-                        <a:rPr sz="1400" b="0">
+                        <a:rPr sz="1500" b="0">
                           <a:solidFill>
                             <a:srgbClr val="1A1A1A"/>
                           </a:solidFill>
@@ -9581,7 +9582,7 @@
                     <a:lstStyle/>
                     <a:p>
                       <a:r>
-                        <a:rPr sz="1400" b="0">
+                        <a:rPr sz="1500" b="0">
                           <a:solidFill>
                             <a:srgbClr val="1A1A1A"/>
                           </a:solidFill>
@@ -9593,14 +9594,14 @@
                   <a:tcPr/>
                 </a:tc>
               </a:tr>
-              <a:tr h="502920">
+              <a:tr h="548640">
                 <a:tc>
                   <a:txBody>
                     <a:bodyPr/>
                     <a:lstStyle/>
                     <a:p>
                       <a:r>
-                        <a:rPr sz="1400" b="0">
+                        <a:rPr sz="1500" b="0">
                           <a:solidFill>
                             <a:srgbClr val="1A1A1A"/>
                           </a:solidFill>
@@ -9617,7 +9618,7 @@
                     <a:lstStyle/>
                     <a:p>
                       <a:r>
-                        <a:rPr sz="1400" b="0">
+                        <a:rPr sz="1500" b="0">
                           <a:solidFill>
                             <a:srgbClr val="1A1A1A"/>
                           </a:solidFill>
@@ -9634,7 +9635,7 @@
                     <a:lstStyle/>
                     <a:p>
                       <a:r>
-                        <a:rPr sz="1400" b="0">
+                        <a:rPr sz="1500" b="0">
                           <a:solidFill>
                             <a:srgbClr val="1A1A1A"/>
                           </a:solidFill>
@@ -9646,14 +9647,14 @@
                   <a:tcPr/>
                 </a:tc>
               </a:tr>
-              <a:tr h="502920">
+              <a:tr h="548640">
                 <a:tc>
                   <a:txBody>
                     <a:bodyPr/>
                     <a:lstStyle/>
                     <a:p>
                       <a:r>
-                        <a:rPr sz="1400" b="0">
+                        <a:rPr sz="1500" b="0">
                           <a:solidFill>
                             <a:srgbClr val="1A1A1A"/>
                           </a:solidFill>
@@ -9670,7 +9671,7 @@
                     <a:lstStyle/>
                     <a:p>
                       <a:r>
-                        <a:rPr sz="1400" b="0">
+                        <a:rPr sz="1500" b="0">
                           <a:solidFill>
                             <a:srgbClr val="1A1A1A"/>
                           </a:solidFill>
@@ -9687,7 +9688,7 @@
                     <a:lstStyle/>
                     <a:p>
                       <a:r>
-                        <a:rPr sz="1400" b="0">
+                        <a:rPr sz="1500" b="0">
                           <a:solidFill>
                             <a:srgbClr val="1A1A1A"/>
                           </a:solidFill>
@@ -9711,8 +9712,8 @@
         </p:nvSpPr>
         <p:spPr>
           <a:xfrm>
-            <a:off x="640080" y="5257800"/>
-            <a:ext cx="10881360" cy="1005840"/>
+            <a:off x="640080" y="6035040"/>
+            <a:ext cx="10881360" cy="365760"/>
           </a:xfrm>
           <a:prstGeom prst="rect">
             <a:avLst/>
@@ -9727,34 +9728,12 @@
           <a:p>
             <a:pPr algn="ctr"/>
             <a:r>
-              <a:rPr sz="1400" b="1" i="0">
+              <a:rPr sz="1500" b="1" i="1">
                 <a:solidFill>
                   <a:srgbClr val="E88B1A"/>
                 </a:solidFill>
               </a:rPr>
-              <a:t>Sem Wi-Fi? O cliente precisa de um roteador ligado depois da ONU.</a:t>
-            </a:r>
-          </a:p>
-          <a:p>
-            <a:pPr algn="ctr"/>
-            <a:r>
-              <a:rPr sz="1400" b="1" i="0">
-                <a:solidFill>
-                  <a:srgbClr val="E88B1A"/>
-                </a:solidFill>
-              </a:rPr>
-              <a:t>Fonte 12V 1,5A liga os dois. A de 1A no HG6143D: falta corrente.</a:t>
-            </a:r>
-          </a:p>
-          <a:p>
-            <a:pPr algn="ctr"/>
-            <a:r>
-              <a:rPr sz="1400" b="1" i="0">
-                <a:solidFill>
-                  <a:srgbClr val="E88B1A"/>
-                </a:solidFill>
-              </a:rPr>
-              <a:t>Trocou a ONU? O provedor precisa do número de série novo pra liberar a internet.</a:t>
+              <a:t>Mesma marca, mesma tensão — e só um deles tem Wi-Fi.</a:t>
             </a:r>
           </a:p>
         </p:txBody>
@@ -9802,6 +9781,368 @@
 </file>
 
 <file path=ppt/slides/slide22.xml><?xml version="1.0" encoding="utf-8"?>
+<p:sld xmlns:a="http://schemas.openxmlformats.org/drawingml/2006/main" xmlns:p="http://schemas.openxmlformats.org/presentationml/2006/main" xmlns:r="http://schemas.openxmlformats.org/officeDocument/2006/relationships">
+  <p:cSld>
+    <p:spTree>
+      <p:nvGrpSpPr>
+        <p:cNvPr id="1" name=""/>
+        <p:cNvGrpSpPr/>
+        <p:nvPr/>
+      </p:nvGrpSpPr>
+      <p:grpSpPr/>
+      <p:sp>
+        <p:nvSpPr>
+          <p:cNvPr id="2" name="Rectangle 1"/>
+          <p:cNvSpPr/>
+          <p:nvPr/>
+        </p:nvSpPr>
+        <p:spPr>
+          <a:xfrm>
+            <a:off x="0" y="0"/>
+            <a:ext cx="12191695" cy="6858000"/>
+          </a:xfrm>
+          <a:prstGeom prst="rect">
+            <a:avLst/>
+          </a:prstGeom>
+          <a:solidFill>
+            <a:srgbClr val="F4F7F7"/>
+          </a:solidFill>
+          <a:ln>
+            <a:noFill/>
+          </a:ln>
+        </p:spPr>
+        <p:style>
+          <a:lnRef idx="1">
+            <a:schemeClr val="accent1"/>
+          </a:lnRef>
+          <a:fillRef idx="3">
+            <a:schemeClr val="accent1"/>
+          </a:fillRef>
+          <a:effectRef idx="2">
+            <a:schemeClr val="accent1"/>
+          </a:effectRef>
+          <a:fontRef idx="minor">
+            <a:schemeClr val="lt1"/>
+          </a:fontRef>
+        </p:style>
+        <p:txBody>
+          <a:bodyPr rtlCol="0" anchor="ctr"/>
+          <a:lstStyle/>
+          <a:p>
+            <a:pPr algn="ctr"/>
+          </a:p>
+        </p:txBody>
+      </p:sp>
+      <p:sp>
+        <p:nvSpPr>
+          <p:cNvPr id="3" name="TextBox 2"/>
+          <p:cNvSpPr txBox="1"/>
+          <p:nvPr/>
+        </p:nvSpPr>
+        <p:spPr>
+          <a:xfrm>
+            <a:off x="640080" y="365760"/>
+            <a:ext cx="10881360" cy="320040"/>
+          </a:xfrm>
+          <a:prstGeom prst="rect">
+            <a:avLst/>
+          </a:prstGeom>
+          <a:noFill/>
+        </p:spPr>
+        <p:txBody>
+          <a:bodyPr wrap="square" lIns="0" rIns="0" tIns="0" bIns="0" anchor="t">
+            <a:spAutoFit/>
+          </a:bodyPr>
+          <a:lstStyle/>
+          <a:p>
+            <a:pPr algn="l"/>
+            <a:r>
+              <a:rPr sz="1300" b="1" i="0">
+                <a:solidFill>
+                  <a:srgbClr val="E88B1A"/>
+                </a:solidFill>
+              </a:rPr>
+              <a:t>CONFERINDO A FICHA · PÁG. 4</a:t>
+            </a:r>
+          </a:p>
+        </p:txBody>
+      </p:sp>
+      <p:sp>
+        <p:nvSpPr>
+          <p:cNvPr id="4" name="TextBox 3"/>
+          <p:cNvSpPr txBox="1"/>
+          <p:nvPr/>
+        </p:nvSpPr>
+        <p:spPr>
+          <a:xfrm>
+            <a:off x="640080" y="685800"/>
+            <a:ext cx="10881360" cy="822960"/>
+          </a:xfrm>
+          <a:prstGeom prst="rect">
+            <a:avLst/>
+          </a:prstGeom>
+          <a:noFill/>
+        </p:spPr>
+        <p:txBody>
+          <a:bodyPr wrap="square" lIns="0" rIns="0" tIns="0" bIns="0" anchor="t">
+            <a:spAutoFit/>
+          </a:bodyPr>
+          <a:lstStyle/>
+          <a:p>
+            <a:pPr algn="l"/>
+            <a:r>
+              <a:rPr sz="3400" b="1" i="0">
+                <a:solidFill>
+                  <a:srgbClr val="0B5C5C"/>
+                </a:solidFill>
+              </a:rPr>
+              <a:t>Pense como técnico · modem de fibra</a:t>
+            </a:r>
+          </a:p>
+        </p:txBody>
+      </p:sp>
+      <p:sp>
+        <p:nvSpPr>
+          <p:cNvPr id="5" name="Rectangle 4"/>
+          <p:cNvSpPr/>
+          <p:nvPr/>
+        </p:nvSpPr>
+        <p:spPr>
+          <a:xfrm>
+            <a:off x="640080" y="1554480"/>
+            <a:ext cx="10881360" cy="54864"/>
+          </a:xfrm>
+          <a:prstGeom prst="rect">
+            <a:avLst/>
+          </a:prstGeom>
+          <a:solidFill>
+            <a:srgbClr val="0B5C5C"/>
+          </a:solidFill>
+          <a:ln>
+            <a:noFill/>
+          </a:ln>
+        </p:spPr>
+        <p:style>
+          <a:lnRef idx="1">
+            <a:schemeClr val="accent1"/>
+          </a:lnRef>
+          <a:fillRef idx="3">
+            <a:schemeClr val="accent1"/>
+          </a:fillRef>
+          <a:effectRef idx="2">
+            <a:schemeClr val="accent1"/>
+          </a:effectRef>
+          <a:fontRef idx="minor">
+            <a:schemeClr val="lt1"/>
+          </a:fontRef>
+        </p:style>
+        <p:txBody>
+          <a:bodyPr rtlCol="0" anchor="ctr"/>
+          <a:lstStyle/>
+          <a:p>
+            <a:pPr algn="ctr"/>
+          </a:p>
+        </p:txBody>
+      </p:sp>
+      <p:sp>
+        <p:nvSpPr>
+          <p:cNvPr id="6" name="TextBox 5"/>
+          <p:cNvSpPr txBox="1"/>
+          <p:nvPr/>
+        </p:nvSpPr>
+        <p:spPr>
+          <a:xfrm>
+            <a:off x="640080" y="2194560"/>
+            <a:ext cx="10881360" cy="3749039"/>
+          </a:xfrm>
+          <a:prstGeom prst="rect">
+            <a:avLst/>
+          </a:prstGeom>
+          <a:noFill/>
+        </p:spPr>
+        <p:txBody>
+          <a:bodyPr wrap="square" lIns="0" rIns="0" tIns="0" bIns="0" anchor="t">
+            <a:spAutoFit/>
+          </a:bodyPr>
+          <a:lstStyle/>
+          <a:p>
+            <a:pPr algn="l"/>
+            <a:r>
+              <a:rPr sz="1600" b="0" i="0">
+                <a:solidFill>
+                  <a:srgbClr val="1A1A1A"/>
+                </a:solidFill>
+              </a:rPr>
+              <a:t>1.  O cliente tem o AN5506-02-B e quer Wi-Fi. O que falta? Onde vai ligado?</a:t>
+            </a:r>
+          </a:p>
+          <a:p>
+            <a:pPr algn="l"/>
+            <a:r>
+              <a:rPr sz="1600" b="0" i="0">
+                <a:solidFill>
+                  <a:srgbClr val="1A1A1A"/>
+                </a:solidFill>
+              </a:rPr>
+              <a:t>     Um roteador. O cabo sai da porta LAN da ONU e entra na porta WAN do roteador.</a:t>
+            </a:r>
+          </a:p>
+          <a:p>
+            <a:pPr algn="l"/>
+            <a:r>
+              <a:rPr sz="1600" b="0" i="0">
+                <a:solidFill>
+                  <a:srgbClr val="1A1A1A"/>
+                </a:solidFill>
+              </a:rPr>
+              <a:t/>
+            </a:r>
+          </a:p>
+          <a:p>
+            <a:pPr algn="l"/>
+            <a:r>
+              <a:rPr sz="1600" b="0" i="0">
+                <a:solidFill>
+                  <a:srgbClr val="1A1A1A"/>
+                </a:solidFill>
+              </a:rPr>
+              <a:t>2.  A fonte de um modem serve no outro?</a:t>
+            </a:r>
+          </a:p>
+          <a:p>
+            <a:pPr algn="l"/>
+            <a:r>
+              <a:rPr sz="1600" b="0" i="0">
+                <a:solidFill>
+                  <a:srgbClr val="1A1A1A"/>
+                </a:solidFill>
+              </a:rPr>
+              <a:t>     Os dois são 12V. A de 1,5A liga o AN5506 (sobra corrente, ele só puxa o que precisa).</a:t>
+            </a:r>
+          </a:p>
+          <a:p>
+            <a:pPr algn="l"/>
+            <a:r>
+              <a:rPr sz="1600" b="0" i="0">
+                <a:solidFill>
+                  <a:srgbClr val="1A1A1A"/>
+                </a:solidFill>
+              </a:rPr>
+              <a:t>     A de 1A no HG6143D NÃO serve: falta corrente, ele reinicia ou esquenta a fonte.</a:t>
+            </a:r>
+          </a:p>
+          <a:p>
+            <a:pPr algn="l"/>
+            <a:r>
+              <a:rPr sz="1600" b="0" i="0">
+                <a:solidFill>
+                  <a:srgbClr val="1A1A1A"/>
+                </a:solidFill>
+              </a:rPr>
+              <a:t/>
+            </a:r>
+          </a:p>
+          <a:p>
+            <a:pPr algn="l"/>
+            <a:r>
+              <a:rPr sz="1600" b="0" i="0">
+                <a:solidFill>
+                  <a:srgbClr val="1A1A1A"/>
+                </a:solidFill>
+              </a:rPr>
+              <a:t>3.  A ONU queimou e você levou outra. O que o provedor vai pedir? Por quê?</a:t>
+            </a:r>
+          </a:p>
+          <a:p>
+            <a:pPr algn="l"/>
+            <a:r>
+              <a:rPr sz="1600" b="0" i="0">
+                <a:solidFill>
+                  <a:srgbClr val="1A1A1A"/>
+                </a:solidFill>
+              </a:rPr>
+              <a:t>     O número de série (GPON SN). É por ele que o provedor reconhece e libera o aparelho.</a:t>
+            </a:r>
+          </a:p>
+        </p:txBody>
+      </p:sp>
+      <p:sp>
+        <p:nvSpPr>
+          <p:cNvPr id="7" name="TextBox 6"/>
+          <p:cNvSpPr txBox="1"/>
+          <p:nvPr/>
+        </p:nvSpPr>
+        <p:spPr>
+          <a:xfrm>
+            <a:off x="640080" y="6035040"/>
+            <a:ext cx="10881360" cy="365760"/>
+          </a:xfrm>
+          <a:prstGeom prst="rect">
+            <a:avLst/>
+          </a:prstGeom>
+          <a:noFill/>
+        </p:spPr>
+        <p:txBody>
+          <a:bodyPr wrap="square" lIns="0" rIns="0" tIns="0" bIns="0" anchor="t">
+            <a:spAutoFit/>
+          </a:bodyPr>
+          <a:lstStyle/>
+          <a:p>
+            <a:pPr algn="ctr"/>
+            <a:r>
+              <a:rPr sz="1400" b="1" i="1">
+                <a:solidFill>
+                  <a:srgbClr val="C5362B"/>
+                </a:solidFill>
+              </a:rPr>
+              <a:t>Tensão tem que ser igual. Corrente da fonte: igual ou maior.</a:t>
+            </a:r>
+          </a:p>
+        </p:txBody>
+      </p:sp>
+      <p:sp>
+        <p:nvSpPr>
+          <p:cNvPr id="8" name="TextBox 7"/>
+          <p:cNvSpPr txBox="1"/>
+          <p:nvPr/>
+        </p:nvSpPr>
+        <p:spPr>
+          <a:xfrm>
+            <a:off x="640080" y="6446520"/>
+            <a:ext cx="10881360" cy="274320"/>
+          </a:xfrm>
+          <a:prstGeom prst="rect">
+            <a:avLst/>
+          </a:prstGeom>
+          <a:noFill/>
+        </p:spPr>
+        <p:txBody>
+          <a:bodyPr wrap="square" lIns="0" rIns="0" tIns="0" bIns="0" anchor="t">
+            <a:spAutoFit/>
+          </a:bodyPr>
+          <a:lstStyle/>
+          <a:p>
+            <a:pPr algn="l"/>
+            <a:r>
+              <a:rPr sz="1000" b="0" i="1">
+                <a:solidFill>
+                  <a:srgbClr val="555555"/>
+                </a:solidFill>
+              </a:rPr>
+              <a:t>Redes de Computadores · Noite 2</a:t>
+            </a:r>
+          </a:p>
+        </p:txBody>
+      </p:sp>
+    </p:spTree>
+  </p:cSld>
+  <p:clrMapOvr>
+    <a:masterClrMapping/>
+  </p:clrMapOvr>
+</p:sld>
+</file>
+
+<file path=ppt/slides/slide23.xml><?xml version="1.0" encoding="utf-8"?>
 <p:sld xmlns:a="http://schemas.openxmlformats.org/drawingml/2006/main" xmlns:p="http://schemas.openxmlformats.org/presentationml/2006/main" xmlns:r="http://schemas.openxmlformats.org/officeDocument/2006/relationships">
   <p:cSld>
     <p:spTree>
@@ -10409,345 +10750,6 @@
 </p:sld>
 </file>
 
-<file path=ppt/slides/slide23.xml><?xml version="1.0" encoding="utf-8"?>
-<p:sld xmlns:a="http://schemas.openxmlformats.org/drawingml/2006/main" xmlns:p="http://schemas.openxmlformats.org/presentationml/2006/main" xmlns:r="http://schemas.openxmlformats.org/officeDocument/2006/relationships">
-  <p:cSld>
-    <p:spTree>
-      <p:nvGrpSpPr>
-        <p:cNvPr id="1" name=""/>
-        <p:cNvGrpSpPr/>
-        <p:nvPr/>
-      </p:nvGrpSpPr>
-      <p:grpSpPr/>
-      <p:sp>
-        <p:nvSpPr>
-          <p:cNvPr id="2" name="Rectangle 1"/>
-          <p:cNvSpPr/>
-          <p:nvPr/>
-        </p:nvSpPr>
-        <p:spPr>
-          <a:xfrm>
-            <a:off x="0" y="0"/>
-            <a:ext cx="12191695" cy="6858000"/>
-          </a:xfrm>
-          <a:prstGeom prst="rect">
-            <a:avLst/>
-          </a:prstGeom>
-          <a:solidFill>
-            <a:srgbClr val="F4F7F7"/>
-          </a:solidFill>
-          <a:ln>
-            <a:noFill/>
-          </a:ln>
-        </p:spPr>
-        <p:style>
-          <a:lnRef idx="1">
-            <a:schemeClr val="accent1"/>
-          </a:lnRef>
-          <a:fillRef idx="3">
-            <a:schemeClr val="accent1"/>
-          </a:fillRef>
-          <a:effectRef idx="2">
-            <a:schemeClr val="accent1"/>
-          </a:effectRef>
-          <a:fontRef idx="minor">
-            <a:schemeClr val="lt1"/>
-          </a:fontRef>
-        </p:style>
-        <p:txBody>
-          <a:bodyPr rtlCol="0" anchor="ctr"/>
-          <a:lstStyle/>
-          <a:p>
-            <a:pPr algn="ctr"/>
-          </a:p>
-        </p:txBody>
-      </p:sp>
-      <p:sp>
-        <p:nvSpPr>
-          <p:cNvPr id="3" name="TextBox 2"/>
-          <p:cNvSpPr txBox="1"/>
-          <p:nvPr/>
-        </p:nvSpPr>
-        <p:spPr>
-          <a:xfrm>
-            <a:off x="640080" y="365760"/>
-            <a:ext cx="10881360" cy="320040"/>
-          </a:xfrm>
-          <a:prstGeom prst="rect">
-            <a:avLst/>
-          </a:prstGeom>
-          <a:noFill/>
-        </p:spPr>
-        <p:txBody>
-          <a:bodyPr wrap="square" lIns="0" rIns="0" tIns="0" bIns="0" anchor="t">
-            <a:spAutoFit/>
-          </a:bodyPr>
-          <a:lstStyle/>
-          <a:p>
-            <a:pPr algn="l"/>
-            <a:r>
-              <a:rPr sz="1300" b="1" i="0">
-                <a:solidFill>
-                  <a:srgbClr val="E88B1A"/>
-                </a:solidFill>
-              </a:rPr>
-              <a:t>PRÁTICA · 30 MIN</a:t>
-            </a:r>
-          </a:p>
-        </p:txBody>
-      </p:sp>
-      <p:sp>
-        <p:nvSpPr>
-          <p:cNvPr id="4" name="TextBox 3"/>
-          <p:cNvSpPr txBox="1"/>
-          <p:nvPr/>
-        </p:nvSpPr>
-        <p:spPr>
-          <a:xfrm>
-            <a:off x="640080" y="685800"/>
-            <a:ext cx="10881360" cy="822960"/>
-          </a:xfrm>
-          <a:prstGeom prst="rect">
-            <a:avLst/>
-          </a:prstGeom>
-          <a:noFill/>
-        </p:spPr>
-        <p:txBody>
-          <a:bodyPr wrap="square" lIns="0" rIns="0" tIns="0" bIns="0" anchor="t">
-            <a:spAutoFit/>
-          </a:bodyPr>
-          <a:lstStyle/>
-          <a:p>
-            <a:pPr algn="l"/>
-            <a:r>
-              <a:rPr sz="3400" b="1" i="0">
-                <a:solidFill>
-                  <a:srgbClr val="0B5C5C"/>
-                </a:solidFill>
-              </a:rPr>
-              <a:t>Role-play: Cliente × Técnico</a:t>
-            </a:r>
-          </a:p>
-        </p:txBody>
-      </p:sp>
-      <p:sp>
-        <p:nvSpPr>
-          <p:cNvPr id="5" name="Rectangle 4"/>
-          <p:cNvSpPr/>
-          <p:nvPr/>
-        </p:nvSpPr>
-        <p:spPr>
-          <a:xfrm>
-            <a:off x="640080" y="1554480"/>
-            <a:ext cx="10881360" cy="54864"/>
-          </a:xfrm>
-          <a:prstGeom prst="rect">
-            <a:avLst/>
-          </a:prstGeom>
-          <a:solidFill>
-            <a:srgbClr val="0B5C5C"/>
-          </a:solidFill>
-          <a:ln>
-            <a:noFill/>
-          </a:ln>
-        </p:spPr>
-        <p:style>
-          <a:lnRef idx="1">
-            <a:schemeClr val="accent1"/>
-          </a:lnRef>
-          <a:fillRef idx="3">
-            <a:schemeClr val="accent1"/>
-          </a:fillRef>
-          <a:effectRef idx="2">
-            <a:schemeClr val="accent1"/>
-          </a:effectRef>
-          <a:fontRef idx="minor">
-            <a:schemeClr val="lt1"/>
-          </a:fontRef>
-        </p:style>
-        <p:txBody>
-          <a:bodyPr rtlCol="0" anchor="ctr"/>
-          <a:lstStyle/>
-          <a:p>
-            <a:pPr algn="ctr"/>
-          </a:p>
-        </p:txBody>
-      </p:sp>
-      <p:sp>
-        <p:nvSpPr>
-          <p:cNvPr id="6" name="TextBox 5"/>
-          <p:cNvSpPr txBox="1"/>
-          <p:nvPr/>
-        </p:nvSpPr>
-        <p:spPr>
-          <a:xfrm>
-            <a:off x="640080" y="2560320"/>
-            <a:ext cx="10881360" cy="3840480"/>
-          </a:xfrm>
-          <a:prstGeom prst="rect">
-            <a:avLst/>
-          </a:prstGeom>
-          <a:noFill/>
-        </p:spPr>
-        <p:txBody>
-          <a:bodyPr wrap="square" lIns="0" rIns="0" tIns="0" bIns="0" anchor="t">
-            <a:spAutoFit/>
-          </a:bodyPr>
-          <a:lstStyle/>
-          <a:p>
-            <a:pPr algn="l"/>
-            <a:r>
-              <a:rPr sz="1500" b="0" i="0">
-                <a:solidFill>
-                  <a:srgbClr val="1A1A1A"/>
-                </a:solidFill>
-              </a:rPr>
-              <a:t>Duplas. Um é o cliente, outro é o técnico.</a:t>
-            </a:r>
-          </a:p>
-          <a:p>
-            <a:pPr algn="l"/>
-            <a:r>
-              <a:rPr sz="1500" b="0" i="0">
-                <a:solidFill>
-                  <a:srgbClr val="1A1A1A"/>
-                </a:solidFill>
-              </a:rPr>
-              <a:t/>
-            </a:r>
-          </a:p>
-          <a:p>
-            <a:pPr algn="l"/>
-            <a:r>
-              <a:rPr sz="1500" b="0" i="0">
-                <a:solidFill>
-                  <a:srgbClr val="1A1A1A"/>
-                </a:solidFill>
-              </a:rPr>
-              <a:t>•  Dupla recebe um cartão de chamado (o técnico NÃO vê)</a:t>
-            </a:r>
-          </a:p>
-          <a:p>
-            <a:pPr algn="l"/>
-            <a:r>
-              <a:rPr sz="1500" b="0" i="0">
-                <a:solidFill>
-                  <a:srgbClr val="1A1A1A"/>
-                </a:solidFill>
-              </a:rPr>
-              <a:t>•  Cliente lê e representa o cliente de verdade — sem vocabulário técnico</a:t>
-            </a:r>
-          </a:p>
-          <a:p>
-            <a:pPr algn="l"/>
-            <a:r>
-              <a:rPr sz="1500" b="0" i="0">
-                <a:solidFill>
-                  <a:srgbClr val="1A1A1A"/>
-                </a:solidFill>
-              </a:rPr>
-              <a:t>•  Técnico faz 3-4 perguntas, aponta o equipamento com problema</a:t>
-            </a:r>
-          </a:p>
-          <a:p>
-            <a:pPr algn="l"/>
-            <a:r>
-              <a:rPr sz="1500" b="0" i="0">
-                <a:solidFill>
-                  <a:srgbClr val="1A1A1A"/>
-                </a:solidFill>
-              </a:rPr>
-              <a:t>     e diz o que investigaria primeiro</a:t>
-            </a:r>
-          </a:p>
-          <a:p>
-            <a:pPr algn="l"/>
-            <a:r>
-              <a:rPr sz="1500" b="0" i="0">
-                <a:solidFill>
-                  <a:srgbClr val="1A1A1A"/>
-                </a:solidFill>
-              </a:rPr>
-              <a:t/>
-            </a:r>
-          </a:p>
-          <a:p>
-            <a:pPr algn="l"/>
-            <a:r>
-              <a:rPr sz="1500" b="0" i="0">
-                <a:solidFill>
-                  <a:srgbClr val="1A1A1A"/>
-                </a:solidFill>
-              </a:rPr>
-              <a:t>•  Depois: troca de papéis, novo cartão</a:t>
-            </a:r>
-          </a:p>
-          <a:p>
-            <a:pPr algn="l"/>
-            <a:r>
-              <a:rPr sz="1500" b="0" i="0">
-                <a:solidFill>
-                  <a:srgbClr val="1A1A1A"/>
-                </a:solidFill>
-              </a:rPr>
-              <a:t/>
-            </a:r>
-          </a:p>
-          <a:p>
-            <a:pPr algn="l"/>
-            <a:r>
-              <a:rPr sz="1500" b="0" i="0">
-                <a:solidFill>
-                  <a:srgbClr val="1A1A1A"/>
-                </a:solidFill>
-              </a:rPr>
-              <a:t>•  Discussão coletiva: 3 duplas contam qual foi o chamado</a:t>
-            </a:r>
-          </a:p>
-        </p:txBody>
-      </p:sp>
-      <p:sp>
-        <p:nvSpPr>
-          <p:cNvPr id="7" name="TextBox 6"/>
-          <p:cNvSpPr txBox="1"/>
-          <p:nvPr/>
-        </p:nvSpPr>
-        <p:spPr>
-          <a:xfrm>
-            <a:off x="640080" y="6446520"/>
-            <a:ext cx="10881360" cy="274320"/>
-          </a:xfrm>
-          <a:prstGeom prst="rect">
-            <a:avLst/>
-          </a:prstGeom>
-          <a:noFill/>
-        </p:spPr>
-        <p:txBody>
-          <a:bodyPr wrap="square" lIns="0" rIns="0" tIns="0" bIns="0" anchor="t">
-            <a:spAutoFit/>
-          </a:bodyPr>
-          <a:lstStyle/>
-          <a:p>
-            <a:pPr algn="l"/>
-            <a:r>
-              <a:rPr sz="1000" b="0" i="1">
-                <a:solidFill>
-                  <a:srgbClr val="555555"/>
-                </a:solidFill>
-              </a:rPr>
-              <a:t>Redes de Computadores · Noite 2</a:t>
-            </a:r>
-          </a:p>
-        </p:txBody>
-      </p:sp>
-    </p:spTree>
-  </p:cSld>
-  <p:clrMapOvr>
-    <a:masterClrMapping/>
-  </p:clrMapOvr>
-</p:sld>
-</file>
-
 <file path=ppt/slides/slide24.xml><?xml version="1.0" encoding="utf-8"?>
 <p:sld xmlns:a="http://schemas.openxmlformats.org/drawingml/2006/main" xmlns:p="http://schemas.openxmlformats.org/presentationml/2006/main" xmlns:r="http://schemas.openxmlformats.org/officeDocument/2006/relationships">
   <p:cSld>
@@ -10830,7 +10832,7 @@
                   <a:srgbClr val="E88B1A"/>
                 </a:solidFill>
               </a:rPr>
-              <a:t>O MÉTODO</a:t>
+              <a:t>PRÁTICA · 30 MIN</a:t>
             </a:r>
           </a:p>
         </p:txBody>
@@ -10864,7 +10866,7 @@
                   <a:srgbClr val="0B5C5C"/>
                 </a:solidFill>
               </a:rPr>
-              <a:t>O que o técnico verifica ao chegar</a:t>
+              <a:t>Role-play: Cliente × Técnico</a:t>
             </a:r>
           </a:p>
         </p:txBody>
@@ -10921,82 +10923,126 @@
         <p:spPr>
           <a:xfrm>
             <a:off x="640080" y="2560320"/>
-            <a:ext cx="10881360" cy="3657600"/>
-          </a:xfrm>
-          <a:prstGeom prst="rect">
-            <a:avLst/>
-          </a:prstGeom>
-          <a:noFill/>
-        </p:spPr>
-        <p:txBody>
-          <a:bodyPr wrap="square" lIns="0" rIns="0" tIns="0" bIns="0" anchor="t">
-            <a:spAutoFit/>
-          </a:bodyPr>
-          <a:lstStyle/>
-          <a:p>
-            <a:pPr algn="l"/>
-            <a:r>
-              <a:rPr sz="1400" b="0" i="0">
+            <a:ext cx="10881360" cy="3840480"/>
+          </a:xfrm>
+          <a:prstGeom prst="rect">
+            <a:avLst/>
+          </a:prstGeom>
+          <a:noFill/>
+        </p:spPr>
+        <p:txBody>
+          <a:bodyPr wrap="square" lIns="0" rIns="0" tIns="0" bIns="0" anchor="t">
+            <a:spAutoFit/>
+          </a:bodyPr>
+          <a:lstStyle/>
+          <a:p>
+            <a:pPr algn="l"/>
+            <a:r>
+              <a:rPr sz="1500" b="0" i="0">
                 <a:solidFill>
                   <a:srgbClr val="1A1A1A"/>
                 </a:solidFill>
               </a:rPr>
-              <a:t>1.  A luz de fibra ou internet está acesa? Se não, o problema é antes do roteador</a:t>
-            </a:r>
-          </a:p>
-          <a:p>
-            <a:pPr algn="l"/>
-            <a:r>
-              <a:rPr sz="1400" b="0" i="0">
+              <a:t>Duplas. Um é o cliente, outro é o técnico.</a:t>
+            </a:r>
+          </a:p>
+          <a:p>
+            <a:pPr algn="l"/>
+            <a:r>
+              <a:rPr sz="1500" b="0" i="0">
                 <a:solidFill>
                   <a:srgbClr val="1A1A1A"/>
                 </a:solidFill>
               </a:rPr>
-              <a:t>2.  Os cabos estão firmes, com clique? Cabo meio solto é campeão de chamado</a:t>
-            </a:r>
-          </a:p>
-          <a:p>
-            <a:pPr algn="l"/>
-            <a:r>
-              <a:rPr sz="1400" b="0" i="0">
+              <a:t/>
+            </a:r>
+          </a:p>
+          <a:p>
+            <a:pPr algn="l"/>
+            <a:r>
+              <a:rPr sz="1500" b="0" i="0">
                 <a:solidFill>
                   <a:srgbClr val="1A1A1A"/>
                 </a:solidFill>
               </a:rPr>
-              <a:t>3.  O cabo do provedor está na porta WAN, e não numa LAN?</a:t>
-            </a:r>
-          </a:p>
-          <a:p>
-            <a:pPr algn="l"/>
-            <a:r>
-              <a:rPr sz="1400" b="0" i="0">
+              <a:t>•  Dupla recebe um cartão de chamado (o técnico NÃO vê)</a:t>
+            </a:r>
+          </a:p>
+          <a:p>
+            <a:pPr algn="l"/>
+            <a:r>
+              <a:rPr sz="1500" b="0" i="0">
                 <a:solidFill>
                   <a:srgbClr val="1A1A1A"/>
                 </a:solidFill>
               </a:rPr>
-              <a:t>4.  Outro aparelho conecta? Se só um falha, o problema é no aparelho</a:t>
-            </a:r>
-          </a:p>
-          <a:p>
-            <a:pPr algn="l"/>
-            <a:r>
-              <a:rPr sz="1400" b="0" i="0">
+              <a:t>•  Cliente lê e representa o cliente de verdade — sem vocabulário técnico</a:t>
+            </a:r>
+          </a:p>
+          <a:p>
+            <a:pPr algn="l"/>
+            <a:r>
+              <a:rPr sz="1500" b="0" i="0">
                 <a:solidFill>
                   <a:srgbClr val="1A1A1A"/>
                 </a:solidFill>
               </a:rPr>
-              <a:t>5.  Conecta na rede mas não abre página? Aí é sinal do provedor</a:t>
-            </a:r>
-          </a:p>
-          <a:p>
-            <a:pPr algn="l"/>
-            <a:r>
-              <a:rPr sz="1400" b="0" i="0">
+              <a:t>•  Técnico faz 3-4 perguntas, aponta o equipamento com problema</a:t>
+            </a:r>
+          </a:p>
+          <a:p>
+            <a:pPr algn="l"/>
+            <a:r>
+              <a:rPr sz="1500" b="0" i="0">
                 <a:solidFill>
                   <a:srgbClr val="1A1A1A"/>
                 </a:solidFill>
               </a:rPr>
-              <a:t>6.  Desligar da tomada por 10 segundos e ligar resolveu? Registre que resolveu.</a:t>
+              <a:t>     e diz o que investigaria primeiro</a:t>
+            </a:r>
+          </a:p>
+          <a:p>
+            <a:pPr algn="l"/>
+            <a:r>
+              <a:rPr sz="1500" b="0" i="0">
+                <a:solidFill>
+                  <a:srgbClr val="1A1A1A"/>
+                </a:solidFill>
+              </a:rPr>
+              <a:t/>
+            </a:r>
+          </a:p>
+          <a:p>
+            <a:pPr algn="l"/>
+            <a:r>
+              <a:rPr sz="1500" b="0" i="0">
+                <a:solidFill>
+                  <a:srgbClr val="1A1A1A"/>
+                </a:solidFill>
+              </a:rPr>
+              <a:t>•  Depois: troca de papéis, novo cartão</a:t>
+            </a:r>
+          </a:p>
+          <a:p>
+            <a:pPr algn="l"/>
+            <a:r>
+              <a:rPr sz="1500" b="0" i="0">
+                <a:solidFill>
+                  <a:srgbClr val="1A1A1A"/>
+                </a:solidFill>
+              </a:rPr>
+              <a:t/>
+            </a:r>
+          </a:p>
+          <a:p>
+            <a:pPr algn="l"/>
+            <a:r>
+              <a:rPr sz="1500" b="0" i="0">
+                <a:solidFill>
+                  <a:srgbClr val="1A1A1A"/>
+                </a:solidFill>
+              </a:rPr>
+              <a:t>•  Discussão coletiva: 3 duplas contam qual foi o chamado</a:t>
             </a:r>
           </a:p>
         </p:txBody>
@@ -11004,40 +11050,6 @@
       <p:sp>
         <p:nvSpPr>
           <p:cNvPr id="7" name="TextBox 6"/>
-          <p:cNvSpPr txBox="1"/>
-          <p:nvPr/>
-        </p:nvSpPr>
-        <p:spPr>
-          <a:xfrm>
-            <a:off x="640080" y="6126480"/>
-            <a:ext cx="10881360" cy="365760"/>
-          </a:xfrm>
-          <a:prstGeom prst="rect">
-            <a:avLst/>
-          </a:prstGeom>
-          <a:noFill/>
-        </p:spPr>
-        <p:txBody>
-          <a:bodyPr wrap="square" lIns="0" rIns="0" tIns="0" bIns="0" anchor="t">
-            <a:spAutoFit/>
-          </a:bodyPr>
-          <a:lstStyle/>
-          <a:p>
-            <a:pPr algn="ctr"/>
-            <a:r>
-              <a:rPr sz="1400" b="0" i="1">
-                <a:solidFill>
-                  <a:srgbClr val="555555"/>
-                </a:solidFill>
-              </a:rPr>
-              <a:t>Sempre na mesma ordem. Método evita retrabalho e troca desnecessária.</a:t>
-            </a:r>
-          </a:p>
-        </p:txBody>
-      </p:sp>
-      <p:sp>
-        <p:nvSpPr>
-          <p:cNvPr id="8" name="TextBox 7"/>
           <p:cNvSpPr txBox="1"/>
           <p:nvPr/>
         </p:nvSpPr>
@@ -11159,7 +11171,7 @@
                   <a:srgbClr val="E88B1A"/>
                 </a:solidFill>
               </a:rPr>
-              <a:t>ENCENAR UM CHAMADO</a:t>
+              <a:t>O MÉTODO</a:t>
             </a:r>
           </a:p>
         </p:txBody>
@@ -11193,7 +11205,7 @@
                   <a:srgbClr val="0B5C5C"/>
                 </a:solidFill>
               </a:rPr>
-              <a:t>Cliente × Técnico ao vivo, turma inteira assiste</a:t>
+              <a:t>O que o técnico verifica ao chegar</a:t>
             </a:r>
           </a:p>
         </p:txBody>
@@ -11250,115 +11262,82 @@
         <p:spPr>
           <a:xfrm>
             <a:off x="640080" y="2560320"/>
-            <a:ext cx="10881360" cy="3840480"/>
-          </a:xfrm>
-          <a:prstGeom prst="rect">
-            <a:avLst/>
-          </a:prstGeom>
-          <a:noFill/>
-        </p:spPr>
-        <p:txBody>
-          <a:bodyPr wrap="square" lIns="0" rIns="0" tIns="0" bIns="0" anchor="t">
-            <a:spAutoFit/>
-          </a:bodyPr>
-          <a:lstStyle/>
-          <a:p>
-            <a:pPr algn="l"/>
-            <a:r>
-              <a:rPr sz="1500" b="0" i="0">
+            <a:ext cx="10881360" cy="3657600"/>
+          </a:xfrm>
+          <a:prstGeom prst="rect">
+            <a:avLst/>
+          </a:prstGeom>
+          <a:noFill/>
+        </p:spPr>
+        <p:txBody>
+          <a:bodyPr wrap="square" lIns="0" rIns="0" tIns="0" bIns="0" anchor="t">
+            <a:spAutoFit/>
+          </a:bodyPr>
+          <a:lstStyle/>
+          <a:p>
+            <a:pPr algn="l"/>
+            <a:r>
+              <a:rPr sz="1400" b="0" i="0">
                 <a:solidFill>
                   <a:srgbClr val="1A1A1A"/>
                 </a:solidFill>
               </a:rPr>
-              <a:t>•  Professor escolhe 2 alunos: 1 cliente, 1 técnico</a:t>
-            </a:r>
-          </a:p>
-          <a:p>
-            <a:pPr algn="l"/>
-            <a:r>
-              <a:rPr sz="1500" b="0" i="0">
+              <a:t>1.  A luz de fibra ou internet está acesa? Se não, o problema é antes do roteador</a:t>
+            </a:r>
+          </a:p>
+          <a:p>
+            <a:pPr algn="l"/>
+            <a:r>
+              <a:rPr sz="1400" b="0" i="0">
                 <a:solidFill>
                   <a:srgbClr val="1A1A1A"/>
                 </a:solidFill>
               </a:rPr>
-              <a:t>•  Professor sussurra o defeito só pro cliente</a:t>
-            </a:r>
-          </a:p>
-          <a:p>
-            <a:pPr algn="l"/>
-            <a:r>
-              <a:rPr sz="1500" b="0" i="0">
+              <a:t>2.  Os cabos estão firmes, com clique? Cabo meio solto é campeão de chamado</a:t>
+            </a:r>
+          </a:p>
+          <a:p>
+            <a:pPr algn="l"/>
+            <a:r>
+              <a:rPr sz="1400" b="0" i="0">
                 <a:solidFill>
                   <a:srgbClr val="1A1A1A"/>
                 </a:solidFill>
               </a:rPr>
-              <a:t>•  Técnico faz perguntas na ordem do método</a:t>
-            </a:r>
-          </a:p>
-          <a:p>
-            <a:pPr algn="l"/>
-            <a:r>
-              <a:rPr sz="1500" b="0" i="0">
+              <a:t>3.  O cabo do provedor está na porta WAN, e não numa LAN?</a:t>
+            </a:r>
+          </a:p>
+          <a:p>
+            <a:pPr algn="l"/>
+            <a:r>
+              <a:rPr sz="1400" b="0" i="0">
                 <a:solidFill>
                   <a:srgbClr val="1A1A1A"/>
                 </a:solidFill>
               </a:rPr>
-              <a:t>•  Turma assiste e ajuda quando o técnico trava</a:t>
-            </a:r>
-          </a:p>
-          <a:p>
-            <a:pPr algn="l"/>
-            <a:r>
-              <a:rPr sz="1500" b="0" i="0">
+              <a:t>4.  Outro aparelho conecta? Se só um falha, o problema é no aparelho</a:t>
+            </a:r>
+          </a:p>
+          <a:p>
+            <a:pPr algn="l"/>
+            <a:r>
+              <a:rPr sz="1400" b="0" i="0">
                 <a:solidFill>
                   <a:srgbClr val="1A1A1A"/>
                 </a:solidFill>
               </a:rPr>
-              <a:t/>
-            </a:r>
-          </a:p>
-          <a:p>
-            <a:pPr algn="l"/>
-            <a:r>
-              <a:rPr sz="1500" b="0" i="0">
+              <a:t>5.  Conecta na rede mas não abre página? Aí é sinal do provedor</a:t>
+            </a:r>
+          </a:p>
+          <a:p>
+            <a:pPr algn="l"/>
+            <a:r>
+              <a:rPr sz="1400" b="0" i="0">
                 <a:solidFill>
                   <a:srgbClr val="1A1A1A"/>
                 </a:solidFill>
               </a:rPr>
-              <a:t>Defeitos que rolam bem:</a:t>
-            </a:r>
-          </a:p>
-          <a:p>
-            <a:pPr algn="l"/>
-            <a:r>
-              <a:rPr sz="1500" b="0" i="0">
-                <a:solidFill>
-                  <a:srgbClr val="1A1A1A"/>
-                </a:solidFill>
-              </a:rPr>
-              <a:t>     •  Cabo do provedor na porta LAN 3</a:t>
-            </a:r>
-          </a:p>
-          <a:p>
-            <a:pPr algn="l"/>
-            <a:r>
-              <a:rPr sz="1500" b="0" i="0">
-                <a:solidFill>
-                  <a:srgbClr val="1A1A1A"/>
-                </a:solidFill>
-              </a:rPr>
-              <a:t>     •  Cabo do computador solto no roteador</a:t>
-            </a:r>
-          </a:p>
-          <a:p>
-            <a:pPr algn="l"/>
-            <a:r>
-              <a:rPr sz="1500" b="0" i="0">
-                <a:solidFill>
-                  <a:srgbClr val="1A1A1A"/>
-                </a:solidFill>
-              </a:rPr>
-              <a:t>     •  Roteador foi resetado e perdeu configuração</a:t>
+              <a:t>6.  Desligar da tomada por 10 segundos e ligar resolveu? Registre que resolveu.</a:t>
             </a:r>
           </a:p>
         </p:txBody>
@@ -11366,6 +11345,40 @@
       <p:sp>
         <p:nvSpPr>
           <p:cNvPr id="7" name="TextBox 6"/>
+          <p:cNvSpPr txBox="1"/>
+          <p:nvPr/>
+        </p:nvSpPr>
+        <p:spPr>
+          <a:xfrm>
+            <a:off x="640080" y="6126480"/>
+            <a:ext cx="10881360" cy="365760"/>
+          </a:xfrm>
+          <a:prstGeom prst="rect">
+            <a:avLst/>
+          </a:prstGeom>
+          <a:noFill/>
+        </p:spPr>
+        <p:txBody>
+          <a:bodyPr wrap="square" lIns="0" rIns="0" tIns="0" bIns="0" anchor="t">
+            <a:spAutoFit/>
+          </a:bodyPr>
+          <a:lstStyle/>
+          <a:p>
+            <a:pPr algn="ctr"/>
+            <a:r>
+              <a:rPr sz="1400" b="0" i="1">
+                <a:solidFill>
+                  <a:srgbClr val="555555"/>
+                </a:solidFill>
+              </a:rPr>
+              <a:t>Sempre na mesma ordem. Método evita retrabalho e troca desnecessária.</a:t>
+            </a:r>
+          </a:p>
+        </p:txBody>
+      </p:sp>
+      <p:sp>
+        <p:nvSpPr>
+          <p:cNvPr id="8" name="TextBox 7"/>
           <p:cNvSpPr txBox="1"/>
           <p:nvPr/>
         </p:nvSpPr>
@@ -11487,7 +11500,7 @@
                   <a:srgbClr val="E88B1A"/>
                 </a:solidFill>
               </a:rPr>
-              <a:t>DUELO RELÂMPAGO · 15 MIN</a:t>
+              <a:t>ENCENAR UM CHAMADO</a:t>
             </a:r>
           </a:p>
         </p:txBody>
@@ -11521,7 +11534,7 @@
                   <a:srgbClr val="0B5C5C"/>
                 </a:solidFill>
               </a:rPr>
-              <a:t>Time A × Time B</a:t>
+              <a:t>Cliente × Técnico ao vivo, turma inteira assiste</a:t>
             </a:r>
           </a:p>
         </p:txBody>
@@ -11593,100 +11606,100 @@
           <a:p>
             <a:pPr algn="l"/>
             <a:r>
-              <a:rPr sz="1700" b="0" i="0">
+              <a:rPr sz="1500" b="0" i="0">
                 <a:solidFill>
                   <a:srgbClr val="1A1A1A"/>
                 </a:solidFill>
               </a:rPr>
-              <a:t>As perguntas de hoje giram em torno de:</a:t>
-            </a:r>
-          </a:p>
-          <a:p>
-            <a:pPr algn="l"/>
-            <a:r>
-              <a:rPr sz="1700" b="0" i="0">
+              <a:t>•  Professor escolhe 2 alunos: 1 cliente, 1 técnico</a:t>
+            </a:r>
+          </a:p>
+          <a:p>
+            <a:pPr algn="l"/>
+            <a:r>
+              <a:rPr sz="1500" b="0" i="0">
                 <a:solidFill>
                   <a:srgbClr val="1A1A1A"/>
                 </a:solidFill>
               </a:rPr>
+              <a:t>•  Professor sussurra o defeito só pro cliente</a:t>
+            </a:r>
+          </a:p>
+          <a:p>
+            <a:pPr algn="l"/>
+            <a:r>
+              <a:rPr sz="1500" b="0" i="0">
+                <a:solidFill>
+                  <a:srgbClr val="1A1A1A"/>
+                </a:solidFill>
+              </a:rPr>
+              <a:t>•  Técnico faz perguntas na ordem do método</a:t>
+            </a:r>
+          </a:p>
+          <a:p>
+            <a:pPr algn="l"/>
+            <a:r>
+              <a:rPr sz="1500" b="0" i="0">
+                <a:solidFill>
+                  <a:srgbClr val="1A1A1A"/>
+                </a:solidFill>
+              </a:rPr>
+              <a:t>•  Turma assiste e ajuda quando o técnico trava</a:t>
+            </a:r>
+          </a:p>
+          <a:p>
+            <a:pPr algn="l"/>
+            <a:r>
+              <a:rPr sz="1500" b="0" i="0">
+                <a:solidFill>
+                  <a:srgbClr val="1A1A1A"/>
+                </a:solidFill>
+              </a:rPr>
               <a:t/>
             </a:r>
           </a:p>
           <a:p>
             <a:pPr algn="l"/>
             <a:r>
-              <a:rPr sz="1700" b="0" i="0">
+              <a:rPr sz="1500" b="0" i="0">
                 <a:solidFill>
                   <a:srgbClr val="1A1A1A"/>
                 </a:solidFill>
               </a:rPr>
-              <a:t>     •  Diferença entre os 5 equipamentos</a:t>
-            </a:r>
-          </a:p>
-          <a:p>
-            <a:pPr algn="l"/>
-            <a:r>
-              <a:rPr sz="1700" b="0" i="0">
+              <a:t>Defeitos que rolam bem:</a:t>
+            </a:r>
+          </a:p>
+          <a:p>
+            <a:pPr algn="l"/>
+            <a:r>
+              <a:rPr sz="1500" b="0" i="0">
                 <a:solidFill>
                   <a:srgbClr val="1A1A1A"/>
                 </a:solidFill>
               </a:rPr>
-              <a:t>     •  Reconhecer a porta WAN</a:t>
-            </a:r>
-          </a:p>
-          <a:p>
-            <a:pPr algn="l"/>
-            <a:r>
-              <a:rPr sz="1700" b="0" i="0">
+              <a:t>     •  Cabo do provedor na porta LAN 3</a:t>
+            </a:r>
+          </a:p>
+          <a:p>
+            <a:pPr algn="l"/>
+            <a:r>
+              <a:rPr sz="1500" b="0" i="0">
                 <a:solidFill>
                   <a:srgbClr val="1A1A1A"/>
                 </a:solidFill>
               </a:rPr>
-              <a:t>     •  Ler as luzes do painel</a:t>
-            </a:r>
-          </a:p>
-          <a:p>
-            <a:pPr algn="l"/>
-            <a:r>
-              <a:rPr sz="1700" b="0" i="0">
+              <a:t>     •  Cabo do computador solto no roteador</a:t>
+            </a:r>
+          </a:p>
+          <a:p>
+            <a:pPr algn="l"/>
+            <a:r>
+              <a:rPr sz="1500" b="0" i="0">
                 <a:solidFill>
                   <a:srgbClr val="1A1A1A"/>
                 </a:solidFill>
               </a:rPr>
-              <a:t>     •  Etapas 1-3 × etapas 4-6</a:t>
-            </a:r>
-          </a:p>
-          <a:p>
-            <a:pPr algn="l"/>
-            <a:r>
-              <a:rPr sz="1700" b="0" i="0">
-                <a:solidFill>
-                  <a:srgbClr val="1A1A1A"/>
-                </a:solidFill>
-              </a:rPr>
-              <a:t>     •  Cenários de chamado</a:t>
-            </a:r>
-          </a:p>
-          <a:p>
-            <a:pPr algn="l"/>
-            <a:r>
-              <a:rPr sz="1700" b="0" i="0">
-                <a:solidFill>
-                  <a:srgbClr val="1A1A1A"/>
-                </a:solidFill>
-              </a:rPr>
-              <a:t/>
-            </a:r>
-          </a:p>
-          <a:p>
-            <a:pPr algn="l"/>
-            <a:r>
-              <a:rPr sz="1700" b="0" i="0">
-                <a:solidFill>
-                  <a:srgbClr val="1A1A1A"/>
-                </a:solidFill>
-              </a:rPr>
-              <a:t>Resposta em 5 segundos. Alterna entre times.</a:t>
+              <a:t>     •  Roteador foi resetado e perdeu configuração</a:t>
             </a:r>
           </a:p>
         </p:txBody>
@@ -11815,7 +11828,7 @@
                   <a:srgbClr val="E88B1A"/>
                 </a:solidFill>
               </a:rPr>
-              <a:t>O RESUMO DA NOITE</a:t>
+              <a:t>DUELO RELÂMPAGO · 15 MIN</a:t>
             </a:r>
           </a:p>
         </p:txBody>
@@ -11849,7 +11862,7 @@
                   <a:srgbClr val="0B5C5C"/>
                 </a:solidFill>
               </a:rPr>
-              <a:t>Não tem internet dentro da caixinha</a:t>
+              <a:t>Time A × Time B</a:t>
             </a:r>
           </a:p>
         </p:txBody>
@@ -11905,34 +11918,34 @@
         </p:nvSpPr>
         <p:spPr>
           <a:xfrm>
-            <a:off x="640080" y="2743200"/>
-            <a:ext cx="10881360" cy="3200400"/>
-          </a:xfrm>
-          <a:prstGeom prst="rect">
-            <a:avLst/>
-          </a:prstGeom>
-          <a:noFill/>
-        </p:spPr>
-        <p:txBody>
-          <a:bodyPr wrap="square" lIns="0" rIns="0" tIns="0" bIns="0" anchor="t">
-            <a:spAutoFit/>
-          </a:bodyPr>
-          <a:lstStyle/>
-          <a:p>
-            <a:pPr algn="l"/>
-            <a:r>
-              <a:rPr sz="2000" b="0" i="0">
+            <a:off x="640080" y="2560320"/>
+            <a:ext cx="10881360" cy="3840480"/>
+          </a:xfrm>
+          <a:prstGeom prst="rect">
+            <a:avLst/>
+          </a:prstGeom>
+          <a:noFill/>
+        </p:spPr>
+        <p:txBody>
+          <a:bodyPr wrap="square" lIns="0" rIns="0" tIns="0" bIns="0" anchor="t">
+            <a:spAutoFit/>
+          </a:bodyPr>
+          <a:lstStyle/>
+          <a:p>
+            <a:pPr algn="l"/>
+            <a:r>
+              <a:rPr sz="1700" b="0" i="0">
                 <a:solidFill>
                   <a:srgbClr val="1A1A1A"/>
                 </a:solidFill>
               </a:rPr>
-              <a:t>•  Ela é só a ponta de um caminho que começa do outro lado do mundo.</a:t>
-            </a:r>
-          </a:p>
-          <a:p>
-            <a:pPr algn="l"/>
-            <a:r>
-              <a:rPr sz="2000" b="0" i="0">
+              <a:t>As perguntas de hoje giram em torno de:</a:t>
+            </a:r>
+          </a:p>
+          <a:p>
+            <a:pPr algn="l"/>
+            <a:r>
+              <a:rPr sz="1700" b="0" i="0">
                 <a:solidFill>
                   <a:srgbClr val="1A1A1A"/>
                 </a:solidFill>
@@ -11943,34 +11956,78 @@
           <a:p>
             <a:pPr algn="l"/>
             <a:r>
-              <a:rPr sz="2000" b="0" i="0">
+              <a:rPr sz="1700" b="0" i="0">
                 <a:solidFill>
                   <a:srgbClr val="1A1A1A"/>
                 </a:solidFill>
               </a:rPr>
-              <a:t>•  Seu trabalho começa no poste da rua e termina na tela do cliente.</a:t>
-            </a:r>
-          </a:p>
-          <a:p>
-            <a:pPr algn="l"/>
-            <a:r>
-              <a:rPr sz="2000" b="0" i="0">
+              <a:t>     •  Diferença entre os 5 equipamentos</a:t>
+            </a:r>
+          </a:p>
+          <a:p>
+            <a:pPr algn="l"/>
+            <a:r>
+              <a:rPr sz="1700" b="0" i="0">
                 <a:solidFill>
                   <a:srgbClr val="1A1A1A"/>
                 </a:solidFill>
               </a:rPr>
+              <a:t>     •  Reconhecer a porta WAN</a:t>
+            </a:r>
+          </a:p>
+          <a:p>
+            <a:pPr algn="l"/>
+            <a:r>
+              <a:rPr sz="1700" b="0" i="0">
+                <a:solidFill>
+                  <a:srgbClr val="1A1A1A"/>
+                </a:solidFill>
+              </a:rPr>
+              <a:t>     •  Ler as luzes do painel</a:t>
+            </a:r>
+          </a:p>
+          <a:p>
+            <a:pPr algn="l"/>
+            <a:r>
+              <a:rPr sz="1700" b="0" i="0">
+                <a:solidFill>
+                  <a:srgbClr val="1A1A1A"/>
+                </a:solidFill>
+              </a:rPr>
+              <a:t>     •  Etapas 1-3 × etapas 4-6</a:t>
+            </a:r>
+          </a:p>
+          <a:p>
+            <a:pPr algn="l"/>
+            <a:r>
+              <a:rPr sz="1700" b="0" i="0">
+                <a:solidFill>
+                  <a:srgbClr val="1A1A1A"/>
+                </a:solidFill>
+              </a:rPr>
+              <a:t>     •  Cenários de chamado</a:t>
+            </a:r>
+          </a:p>
+          <a:p>
+            <a:pPr algn="l"/>
+            <a:r>
+              <a:rPr sz="1700" b="0" i="0">
+                <a:solidFill>
+                  <a:srgbClr val="1A1A1A"/>
+                </a:solidFill>
+              </a:rPr>
               <a:t/>
             </a:r>
           </a:p>
           <a:p>
             <a:pPr algn="l"/>
             <a:r>
-              <a:rPr sz="2000" b="0" i="0">
+              <a:rPr sz="1700" b="0" i="0">
                 <a:solidFill>
                   <a:srgbClr val="1A1A1A"/>
                 </a:solidFill>
               </a:rPr>
-              <a:t>•  Tudo que vem antes disso é com o provedor.</a:t>
+              <a:t>Resposta em 5 segundos. Alterna entre times.</a:t>
             </a:r>
           </a:p>
         </p:txBody>
@@ -12099,7 +12156,7 @@
                   <a:srgbClr val="E88B1A"/>
                 </a:solidFill>
               </a:rPr>
-              <a:t>FECHANDO</a:t>
+              <a:t>O RESUMO DA NOITE</a:t>
             </a:r>
           </a:p>
         </p:txBody>
@@ -12133,7 +12190,7 @@
                   <a:srgbClr val="0B5C5C"/>
                 </a:solidFill>
               </a:rPr>
-              <a:t>Seis perguntas para conferir</a:t>
+              <a:t>Não tem internet dentro da caixinha</a:t>
             </a:r>
           </a:p>
         </p:txBody>
@@ -12189,83 +12246,72 @@
         </p:nvSpPr>
         <p:spPr>
           <a:xfrm>
-            <a:off x="640080" y="2560320"/>
-            <a:ext cx="10881360" cy="3657600"/>
-          </a:xfrm>
-          <a:prstGeom prst="rect">
-            <a:avLst/>
-          </a:prstGeom>
-          <a:noFill/>
-        </p:spPr>
-        <p:txBody>
-          <a:bodyPr wrap="square" lIns="0" rIns="0" tIns="0" bIns="0" anchor="t">
-            <a:spAutoFit/>
-          </a:bodyPr>
-          <a:lstStyle/>
-          <a:p>
-            <a:pPr algn="l"/>
-            <a:r>
-              <a:rPr sz="1600" b="0" i="0">
+            <a:off x="640080" y="2743200"/>
+            <a:ext cx="10881360" cy="3200400"/>
+          </a:xfrm>
+          <a:prstGeom prst="rect">
+            <a:avLst/>
+          </a:prstGeom>
+          <a:noFill/>
+        </p:spPr>
+        <p:txBody>
+          <a:bodyPr wrap="square" lIns="0" rIns="0" tIns="0" bIns="0" anchor="t">
+            <a:spAutoFit/>
+          </a:bodyPr>
+          <a:lstStyle/>
+          <a:p>
+            <a:pPr algn="l"/>
+            <a:r>
+              <a:rPr sz="2000" b="0" i="0">
                 <a:solidFill>
                   <a:srgbClr val="1A1A1A"/>
                 </a:solidFill>
               </a:rPr>
-              <a:t>1.  Qual é a diferença entre modem e roteador?</a:t>
-            </a:r>
-          </a:p>
-          <a:p>
-            <a:pPr algn="l"/>
-            <a:r>
-              <a:rPr sz="1600" b="0" i="0">
+              <a:t>•  Ela é só a ponta de um caminho que começa do outro lado do mundo.</a:t>
+            </a:r>
+          </a:p>
+          <a:p>
+            <a:pPr algn="l"/>
+            <a:r>
+              <a:rPr sz="2000" b="0" i="0">
                 <a:solidFill>
                   <a:srgbClr val="1A1A1A"/>
                 </a:solidFill>
               </a:rPr>
-              <a:t>2.  O switch cria rede? O que ele faz então?</a:t>
-            </a:r>
-          </a:p>
-          <a:p>
-            <a:pPr algn="l"/>
-            <a:r>
-              <a:rPr sz="1600" b="0" i="0">
+              <a:t/>
+            </a:r>
+          </a:p>
+          <a:p>
+            <a:pPr algn="l"/>
+            <a:r>
+              <a:rPr sz="2000" b="0" i="0">
                 <a:solidFill>
                   <a:srgbClr val="1A1A1A"/>
                 </a:solidFill>
               </a:rPr>
-              <a:t>3.  Como você reconhece a porta WAN num roteador que nunca viu?</a:t>
-            </a:r>
-          </a:p>
-          <a:p>
-            <a:pPr algn="l"/>
-            <a:r>
-              <a:rPr sz="1600" b="0" i="0">
+              <a:t>•  Seu trabalho começa no poste da rua e termina na tela do cliente.</a:t>
+            </a:r>
+          </a:p>
+          <a:p>
+            <a:pPr algn="l"/>
+            <a:r>
+              <a:rPr sz="2000" b="0" i="0">
                 <a:solidFill>
                   <a:srgbClr val="1A1A1A"/>
                 </a:solidFill>
               </a:rPr>
-              <a:t>4.  O que acontece se o cabo do provedor for ligado numa porta LAN?</a:t>
-            </a:r>
-          </a:p>
-          <a:p>
-            <a:pPr algn="l"/>
-            <a:r>
-              <a:rPr sz="1600" b="0" i="0">
+              <a:t/>
+            </a:r>
+          </a:p>
+          <a:p>
+            <a:pPr algn="l"/>
+            <a:r>
+              <a:rPr sz="2000" b="0" i="0">
                 <a:solidFill>
                   <a:srgbClr val="1A1A1A"/>
                 </a:solidFill>
               </a:rPr>
-              <a:t>5.  Por que o Wi-Fi do quarto costuma ser pior que o da sala?</a:t>
-            </a:r>
-          </a:p>
-          <a:p>
-            <a:pPr algn="l"/>
-            <a:r>
-              <a:rPr sz="1600" b="0" i="0">
-                <a:solidFill>
-                  <a:srgbClr val="1A1A1A"/>
-                </a:solidFill>
-              </a:rPr>
-              <a:t>6.  A luz de fibra está apagada. Onde está o problema?</a:t>
+              <a:t>•  Tudo que vem antes disso é com o provedor.</a:t>
             </a:r>
           </a:p>
         </p:txBody>
@@ -12394,7 +12440,7 @@
                   <a:srgbClr val="E88B1A"/>
                 </a:solidFill>
               </a:rPr>
-              <a:t>O QUE FICA DESTA NOITE</a:t>
+              <a:t>FECHANDO</a:t>
             </a:r>
           </a:p>
         </p:txBody>
@@ -12428,7 +12474,7 @@
                   <a:srgbClr val="0B5C5C"/>
                 </a:solidFill>
               </a:rPr>
-              <a:t>Cinco coisas para levar</a:t>
+              <a:t>Seis perguntas para conferir</a:t>
             </a:r>
           </a:p>
         </p:txBody>
@@ -12484,72 +12530,83 @@
         </p:nvSpPr>
         <p:spPr>
           <a:xfrm>
-            <a:off x="640080" y="2743200"/>
-            <a:ext cx="10881360" cy="3200400"/>
-          </a:xfrm>
-          <a:prstGeom prst="rect">
-            <a:avLst/>
-          </a:prstGeom>
-          <a:noFill/>
-        </p:spPr>
-        <p:txBody>
-          <a:bodyPr wrap="square" lIns="0" rIns="0" tIns="0" bIns="0" anchor="t">
-            <a:spAutoFit/>
-          </a:bodyPr>
-          <a:lstStyle/>
-          <a:p>
-            <a:pPr algn="l"/>
-            <a:r>
-              <a:rPr sz="1700" b="0" i="0">
+            <a:off x="640080" y="2560320"/>
+            <a:ext cx="10881360" cy="3657600"/>
+          </a:xfrm>
+          <a:prstGeom prst="rect">
+            <a:avLst/>
+          </a:prstGeom>
+          <a:noFill/>
+        </p:spPr>
+        <p:txBody>
+          <a:bodyPr wrap="square" lIns="0" rIns="0" tIns="0" bIns="0" anchor="t">
+            <a:spAutoFit/>
+          </a:bodyPr>
+          <a:lstStyle/>
+          <a:p>
+            <a:pPr algn="l"/>
+            <a:r>
+              <a:rPr sz="1600" b="0" i="0">
                 <a:solidFill>
                   <a:srgbClr val="1A1A1A"/>
                 </a:solidFill>
               </a:rPr>
-              <a:t>•  A internet vem de longe e passa por seis etapas até você</a:t>
-            </a:r>
-          </a:p>
-          <a:p>
-            <a:pPr algn="l"/>
-            <a:r>
-              <a:rPr sz="1700" b="0" i="0">
+              <a:t>1.  Qual é a diferença entre modem e roteador?</a:t>
+            </a:r>
+          </a:p>
+          <a:p>
+            <a:pPr algn="l"/>
+            <a:r>
+              <a:rPr sz="1600" b="0" i="0">
                 <a:solidFill>
                   <a:srgbClr val="1A1A1A"/>
                 </a:solidFill>
               </a:rPr>
-              <a:t>•  Só o roteador cria rede — os outros ajudam</a:t>
-            </a:r>
-          </a:p>
-          <a:p>
-            <a:pPr algn="l"/>
-            <a:r>
-              <a:rPr sz="1700" b="0" i="0">
+              <a:t>2.  O switch cria rede? O que ele faz então?</a:t>
+            </a:r>
+          </a:p>
+          <a:p>
+            <a:pPr algn="l"/>
+            <a:r>
+              <a:rPr sz="1600" b="0" i="0">
                 <a:solidFill>
                   <a:srgbClr val="1A1A1A"/>
                 </a:solidFill>
               </a:rPr>
-              <a:t>•  A porta WAN é diferente, e trocar ela é o erro mais comum</a:t>
-            </a:r>
-          </a:p>
-          <a:p>
-            <a:pPr algn="l"/>
-            <a:r>
-              <a:rPr sz="1700" b="0" i="0">
+              <a:t>3.  Como você reconhece a porta WAN num roteador que nunca viu?</a:t>
+            </a:r>
+          </a:p>
+          <a:p>
+            <a:pPr algn="l"/>
+            <a:r>
+              <a:rPr sz="1600" b="0" i="0">
                 <a:solidFill>
                   <a:srgbClr val="1A1A1A"/>
                 </a:solidFill>
               </a:rPr>
-              <a:t>•  A etiqueta embaixo tem tudo que o suporte vai pedir</a:t>
-            </a:r>
-          </a:p>
-          <a:p>
-            <a:pPr algn="l"/>
-            <a:r>
-              <a:rPr sz="1700" b="0" i="0">
+              <a:t>4.  O que acontece se o cabo do provedor for ligado numa porta LAN?</a:t>
+            </a:r>
+          </a:p>
+          <a:p>
+            <a:pPr algn="l"/>
+            <a:r>
+              <a:rPr sz="1600" b="0" i="0">
                 <a:solidFill>
                   <a:srgbClr val="1A1A1A"/>
                 </a:solidFill>
               </a:rPr>
-              <a:t>•  As luzes do painel dizem onde está o problema antes de você abrir nada</a:t>
+              <a:t>5.  Por que o Wi-Fi do quarto costuma ser pior que o da sala?</a:t>
+            </a:r>
+          </a:p>
+          <a:p>
+            <a:pPr algn="l"/>
+            <a:r>
+              <a:rPr sz="1600" b="0" i="0">
+                <a:solidFill>
+                  <a:srgbClr val="1A1A1A"/>
+                </a:solidFill>
+              </a:rPr>
+              <a:t>6.  A luz de fibra está apagada. Onde está o problema?</a:t>
             </a:r>
           </a:p>
         </p:txBody>
@@ -12949,6 +13006,290 @@
 </file>
 
 <file path=ppt/slides/slide30.xml><?xml version="1.0" encoding="utf-8"?>
+<p:sld xmlns:a="http://schemas.openxmlformats.org/drawingml/2006/main" xmlns:p="http://schemas.openxmlformats.org/presentationml/2006/main" xmlns:r="http://schemas.openxmlformats.org/officeDocument/2006/relationships">
+  <p:cSld>
+    <p:spTree>
+      <p:nvGrpSpPr>
+        <p:cNvPr id="1" name=""/>
+        <p:cNvGrpSpPr/>
+        <p:nvPr/>
+      </p:nvGrpSpPr>
+      <p:grpSpPr/>
+      <p:sp>
+        <p:nvSpPr>
+          <p:cNvPr id="2" name="Rectangle 1"/>
+          <p:cNvSpPr/>
+          <p:nvPr/>
+        </p:nvSpPr>
+        <p:spPr>
+          <a:xfrm>
+            <a:off x="0" y="0"/>
+            <a:ext cx="12191695" cy="6858000"/>
+          </a:xfrm>
+          <a:prstGeom prst="rect">
+            <a:avLst/>
+          </a:prstGeom>
+          <a:solidFill>
+            <a:srgbClr val="F4F7F7"/>
+          </a:solidFill>
+          <a:ln>
+            <a:noFill/>
+          </a:ln>
+        </p:spPr>
+        <p:style>
+          <a:lnRef idx="1">
+            <a:schemeClr val="accent1"/>
+          </a:lnRef>
+          <a:fillRef idx="3">
+            <a:schemeClr val="accent1"/>
+          </a:fillRef>
+          <a:effectRef idx="2">
+            <a:schemeClr val="accent1"/>
+          </a:effectRef>
+          <a:fontRef idx="minor">
+            <a:schemeClr val="lt1"/>
+          </a:fontRef>
+        </p:style>
+        <p:txBody>
+          <a:bodyPr rtlCol="0" anchor="ctr"/>
+          <a:lstStyle/>
+          <a:p>
+            <a:pPr algn="ctr"/>
+          </a:p>
+        </p:txBody>
+      </p:sp>
+      <p:sp>
+        <p:nvSpPr>
+          <p:cNvPr id="3" name="TextBox 2"/>
+          <p:cNvSpPr txBox="1"/>
+          <p:nvPr/>
+        </p:nvSpPr>
+        <p:spPr>
+          <a:xfrm>
+            <a:off x="640080" y="365760"/>
+            <a:ext cx="10881360" cy="320040"/>
+          </a:xfrm>
+          <a:prstGeom prst="rect">
+            <a:avLst/>
+          </a:prstGeom>
+          <a:noFill/>
+        </p:spPr>
+        <p:txBody>
+          <a:bodyPr wrap="square" lIns="0" rIns="0" tIns="0" bIns="0" anchor="t">
+            <a:spAutoFit/>
+          </a:bodyPr>
+          <a:lstStyle/>
+          <a:p>
+            <a:pPr algn="l"/>
+            <a:r>
+              <a:rPr sz="1300" b="1" i="0">
+                <a:solidFill>
+                  <a:srgbClr val="E88B1A"/>
+                </a:solidFill>
+              </a:rPr>
+              <a:t>O QUE FICA DESTA NOITE</a:t>
+            </a:r>
+          </a:p>
+        </p:txBody>
+      </p:sp>
+      <p:sp>
+        <p:nvSpPr>
+          <p:cNvPr id="4" name="TextBox 3"/>
+          <p:cNvSpPr txBox="1"/>
+          <p:nvPr/>
+        </p:nvSpPr>
+        <p:spPr>
+          <a:xfrm>
+            <a:off x="640080" y="685800"/>
+            <a:ext cx="10881360" cy="822960"/>
+          </a:xfrm>
+          <a:prstGeom prst="rect">
+            <a:avLst/>
+          </a:prstGeom>
+          <a:noFill/>
+        </p:spPr>
+        <p:txBody>
+          <a:bodyPr wrap="square" lIns="0" rIns="0" tIns="0" bIns="0" anchor="t">
+            <a:spAutoFit/>
+          </a:bodyPr>
+          <a:lstStyle/>
+          <a:p>
+            <a:pPr algn="l"/>
+            <a:r>
+              <a:rPr sz="3400" b="1" i="0">
+                <a:solidFill>
+                  <a:srgbClr val="0B5C5C"/>
+                </a:solidFill>
+              </a:rPr>
+              <a:t>Cinco coisas para levar</a:t>
+            </a:r>
+          </a:p>
+        </p:txBody>
+      </p:sp>
+      <p:sp>
+        <p:nvSpPr>
+          <p:cNvPr id="5" name="Rectangle 4"/>
+          <p:cNvSpPr/>
+          <p:nvPr/>
+        </p:nvSpPr>
+        <p:spPr>
+          <a:xfrm>
+            <a:off x="640080" y="1554480"/>
+            <a:ext cx="10881360" cy="54864"/>
+          </a:xfrm>
+          <a:prstGeom prst="rect">
+            <a:avLst/>
+          </a:prstGeom>
+          <a:solidFill>
+            <a:srgbClr val="0B5C5C"/>
+          </a:solidFill>
+          <a:ln>
+            <a:noFill/>
+          </a:ln>
+        </p:spPr>
+        <p:style>
+          <a:lnRef idx="1">
+            <a:schemeClr val="accent1"/>
+          </a:lnRef>
+          <a:fillRef idx="3">
+            <a:schemeClr val="accent1"/>
+          </a:fillRef>
+          <a:effectRef idx="2">
+            <a:schemeClr val="accent1"/>
+          </a:effectRef>
+          <a:fontRef idx="minor">
+            <a:schemeClr val="lt1"/>
+          </a:fontRef>
+        </p:style>
+        <p:txBody>
+          <a:bodyPr rtlCol="0" anchor="ctr"/>
+          <a:lstStyle/>
+          <a:p>
+            <a:pPr algn="ctr"/>
+          </a:p>
+        </p:txBody>
+      </p:sp>
+      <p:sp>
+        <p:nvSpPr>
+          <p:cNvPr id="6" name="TextBox 5"/>
+          <p:cNvSpPr txBox="1"/>
+          <p:nvPr/>
+        </p:nvSpPr>
+        <p:spPr>
+          <a:xfrm>
+            <a:off x="640080" y="2743200"/>
+            <a:ext cx="10881360" cy="3200400"/>
+          </a:xfrm>
+          <a:prstGeom prst="rect">
+            <a:avLst/>
+          </a:prstGeom>
+          <a:noFill/>
+        </p:spPr>
+        <p:txBody>
+          <a:bodyPr wrap="square" lIns="0" rIns="0" tIns="0" bIns="0" anchor="t">
+            <a:spAutoFit/>
+          </a:bodyPr>
+          <a:lstStyle/>
+          <a:p>
+            <a:pPr algn="l"/>
+            <a:r>
+              <a:rPr sz="1700" b="0" i="0">
+                <a:solidFill>
+                  <a:srgbClr val="1A1A1A"/>
+                </a:solidFill>
+              </a:rPr>
+              <a:t>•  A internet vem de longe e passa por seis etapas até você</a:t>
+            </a:r>
+          </a:p>
+          <a:p>
+            <a:pPr algn="l"/>
+            <a:r>
+              <a:rPr sz="1700" b="0" i="0">
+                <a:solidFill>
+                  <a:srgbClr val="1A1A1A"/>
+                </a:solidFill>
+              </a:rPr>
+              <a:t>•  Só o roteador cria rede — os outros ajudam</a:t>
+            </a:r>
+          </a:p>
+          <a:p>
+            <a:pPr algn="l"/>
+            <a:r>
+              <a:rPr sz="1700" b="0" i="0">
+                <a:solidFill>
+                  <a:srgbClr val="1A1A1A"/>
+                </a:solidFill>
+              </a:rPr>
+              <a:t>•  A porta WAN é diferente, e trocar ela é o erro mais comum</a:t>
+            </a:r>
+          </a:p>
+          <a:p>
+            <a:pPr algn="l"/>
+            <a:r>
+              <a:rPr sz="1700" b="0" i="0">
+                <a:solidFill>
+                  <a:srgbClr val="1A1A1A"/>
+                </a:solidFill>
+              </a:rPr>
+              <a:t>•  A etiqueta embaixo tem tudo que o suporte vai pedir</a:t>
+            </a:r>
+          </a:p>
+          <a:p>
+            <a:pPr algn="l"/>
+            <a:r>
+              <a:rPr sz="1700" b="0" i="0">
+                <a:solidFill>
+                  <a:srgbClr val="1A1A1A"/>
+                </a:solidFill>
+              </a:rPr>
+              <a:t>•  As luzes do painel dizem onde está o problema antes de você abrir nada</a:t>
+            </a:r>
+          </a:p>
+        </p:txBody>
+      </p:sp>
+      <p:sp>
+        <p:nvSpPr>
+          <p:cNvPr id="7" name="TextBox 6"/>
+          <p:cNvSpPr txBox="1"/>
+          <p:nvPr/>
+        </p:nvSpPr>
+        <p:spPr>
+          <a:xfrm>
+            <a:off x="640080" y="6446520"/>
+            <a:ext cx="10881360" cy="274320"/>
+          </a:xfrm>
+          <a:prstGeom prst="rect">
+            <a:avLst/>
+          </a:prstGeom>
+          <a:noFill/>
+        </p:spPr>
+        <p:txBody>
+          <a:bodyPr wrap="square" lIns="0" rIns="0" tIns="0" bIns="0" anchor="t">
+            <a:spAutoFit/>
+          </a:bodyPr>
+          <a:lstStyle/>
+          <a:p>
+            <a:pPr algn="l"/>
+            <a:r>
+              <a:rPr sz="1000" b="0" i="1">
+                <a:solidFill>
+                  <a:srgbClr val="555555"/>
+                </a:solidFill>
+              </a:rPr>
+              <a:t>Redes de Computadores · Noite 2</a:t>
+            </a:r>
+          </a:p>
+        </p:txBody>
+      </p:sp>
+    </p:spTree>
+  </p:cSld>
+  <p:clrMapOvr>
+    <a:masterClrMapping/>
+  </p:clrMapOvr>
+</p:sld>
+</file>
+
+<file path=ppt/slides/slide31.xml><?xml version="1.0" encoding="utf-8"?>
 <p:sld xmlns:a="http://schemas.openxmlformats.org/drawingml/2006/main" xmlns:p="http://schemas.openxmlformats.org/presentationml/2006/main" xmlns:r="http://schemas.openxmlformats.org/officeDocument/2006/relationships">
   <p:cSld>
     <p:spTree>

</xml_diff>